<commit_message>
Changed scenario and rewrite the developments_roadmap.md file.
</commit_message>
<xml_diff>
--- a/documents/scenario_and_prd/work_space.pptx
+++ b/documents/scenario_and_prd/work_space.pptx
@@ -3327,12 +3327,625 @@
           <a:chExt cx="0" cy="0"/>
         </a:xfrm>
       </p:grpSpPr>
+      <p:sp>
+        <p:nvSpPr>
+          <p:cNvPr id="2" name="직사각형 1">
+            <a:extLst>
+              <a:ext uri="{FF2B5EF4-FFF2-40B4-BE49-F238E27FC236}">
+                <a16:creationId xmlns:a16="http://schemas.microsoft.com/office/drawing/2014/main" id="{E74C06BE-6EAF-481A-884E-1E685522BEF6}"/>
+              </a:ext>
+            </a:extLst>
+          </p:cNvPr>
+          <p:cNvSpPr/>
+          <p:nvPr/>
+        </p:nvSpPr>
+        <p:spPr>
+          <a:xfrm>
+            <a:off x="1559878" y="1576211"/>
+            <a:ext cx="1513556" cy="1995311"/>
+          </a:xfrm>
+          <a:prstGeom prst="rect">
+            <a:avLst/>
+          </a:prstGeom>
+        </p:spPr>
+        <p:style>
+          <a:lnRef idx="2">
+            <a:schemeClr val="accent1">
+              <a:shade val="50000"/>
+            </a:schemeClr>
+          </a:lnRef>
+          <a:fillRef idx="1">
+            <a:schemeClr val="accent1"/>
+          </a:fillRef>
+          <a:effectRef idx="0">
+            <a:schemeClr val="accent1"/>
+          </a:effectRef>
+          <a:fontRef idx="minor">
+            <a:schemeClr val="lt1"/>
+          </a:fontRef>
+        </p:style>
+        <p:txBody>
+          <a:bodyPr rtlCol="0" anchor="ctr"/>
+          <a:lstStyle/>
+          <a:p>
+            <a:pPr algn="ctr"/>
+            <a:r>
+              <a:rPr lang="ko-KR" altLang="en-US" sz="1400" dirty="0"/>
+              <a:t>부품</a:t>
+            </a:r>
+            <a:endParaRPr lang="en-US" altLang="ko-KR" sz="1400" dirty="0"/>
+          </a:p>
+          <a:p>
+            <a:pPr algn="ctr"/>
+            <a:r>
+              <a:rPr lang="ko-KR" altLang="en-US" sz="1400" dirty="0"/>
+              <a:t>적재함</a:t>
+            </a:r>
+            <a:endParaRPr lang="ko-KR" altLang="en-US" dirty="0"/>
+          </a:p>
+        </p:txBody>
+      </p:sp>
+      <p:sp>
+        <p:nvSpPr>
+          <p:cNvPr id="3" name="타원 2">
+            <a:extLst>
+              <a:ext uri="{FF2B5EF4-FFF2-40B4-BE49-F238E27FC236}">
+                <a16:creationId xmlns:a16="http://schemas.microsoft.com/office/drawing/2014/main" id="{E4600936-A723-4262-9187-DBE37F6CA8D0}"/>
+              </a:ext>
+            </a:extLst>
+          </p:cNvPr>
+          <p:cNvSpPr/>
+          <p:nvPr/>
+        </p:nvSpPr>
+        <p:spPr>
+          <a:xfrm>
+            <a:off x="3929767" y="2349151"/>
+            <a:ext cx="880533" cy="869244"/>
+          </a:xfrm>
+          <a:prstGeom prst="ellipse">
+            <a:avLst/>
+          </a:prstGeom>
+        </p:spPr>
+        <p:style>
+          <a:lnRef idx="2">
+            <a:schemeClr val="accent1">
+              <a:shade val="50000"/>
+            </a:schemeClr>
+          </a:lnRef>
+          <a:fillRef idx="1">
+            <a:schemeClr val="accent1"/>
+          </a:fillRef>
+          <a:effectRef idx="0">
+            <a:schemeClr val="accent1"/>
+          </a:effectRef>
+          <a:fontRef idx="minor">
+            <a:schemeClr val="lt1"/>
+          </a:fontRef>
+        </p:style>
+        <p:txBody>
+          <a:bodyPr rtlCol="0" anchor="ctr"/>
+          <a:lstStyle/>
+          <a:p>
+            <a:pPr algn="ctr"/>
+            <a:r>
+              <a:rPr lang="ko-KR" altLang="en-US" sz="1400" dirty="0"/>
+              <a:t>로봇</a:t>
+            </a:r>
+            <a:r>
+              <a:rPr lang="en-US" altLang="ko-KR" sz="1400" dirty="0"/>
+              <a:t>1</a:t>
+            </a:r>
+            <a:endParaRPr lang="ko-KR" altLang="en-US" sz="1400" dirty="0"/>
+          </a:p>
+        </p:txBody>
+      </p:sp>
+      <p:sp>
+        <p:nvSpPr>
+          <p:cNvPr id="20" name="타원 19">
+            <a:extLst>
+              <a:ext uri="{FF2B5EF4-FFF2-40B4-BE49-F238E27FC236}">
+                <a16:creationId xmlns:a16="http://schemas.microsoft.com/office/drawing/2014/main" id="{84ACEA36-FD47-458B-980C-D3E08139C069}"/>
+              </a:ext>
+            </a:extLst>
+          </p:cNvPr>
+          <p:cNvSpPr/>
+          <p:nvPr/>
+        </p:nvSpPr>
+        <p:spPr>
+          <a:xfrm>
+            <a:off x="7403500" y="2349151"/>
+            <a:ext cx="880533" cy="869244"/>
+          </a:xfrm>
+          <a:prstGeom prst="ellipse">
+            <a:avLst/>
+          </a:prstGeom>
+        </p:spPr>
+        <p:style>
+          <a:lnRef idx="2">
+            <a:schemeClr val="accent1">
+              <a:shade val="50000"/>
+            </a:schemeClr>
+          </a:lnRef>
+          <a:fillRef idx="1">
+            <a:schemeClr val="accent1"/>
+          </a:fillRef>
+          <a:effectRef idx="0">
+            <a:schemeClr val="accent1"/>
+          </a:effectRef>
+          <a:fontRef idx="minor">
+            <a:schemeClr val="lt1"/>
+          </a:fontRef>
+        </p:style>
+        <p:txBody>
+          <a:bodyPr rtlCol="0" anchor="ctr"/>
+          <a:lstStyle/>
+          <a:p>
+            <a:pPr algn="ctr"/>
+            <a:r>
+              <a:rPr lang="ko-KR" altLang="en-US" sz="1400" dirty="0"/>
+              <a:t>로봇</a:t>
+            </a:r>
+            <a:r>
+              <a:rPr lang="en-US" altLang="ko-KR" sz="1400" dirty="0"/>
+              <a:t>2</a:t>
+            </a:r>
+            <a:endParaRPr lang="ko-KR" altLang="en-US" sz="1400" dirty="0"/>
+          </a:p>
+        </p:txBody>
+      </p:sp>
+      <p:sp>
+        <p:nvSpPr>
+          <p:cNvPr id="5" name="직사각형 4">
+            <a:extLst>
+              <a:ext uri="{FF2B5EF4-FFF2-40B4-BE49-F238E27FC236}">
+                <a16:creationId xmlns:a16="http://schemas.microsoft.com/office/drawing/2014/main" id="{4CD68C48-AD1A-4C41-A802-027542CB4067}"/>
+              </a:ext>
+            </a:extLst>
+          </p:cNvPr>
+          <p:cNvSpPr/>
+          <p:nvPr/>
+        </p:nvSpPr>
+        <p:spPr>
+          <a:xfrm>
+            <a:off x="3073434" y="3753557"/>
+            <a:ext cx="6045132" cy="1350431"/>
+          </a:xfrm>
+          <a:prstGeom prst="rect">
+            <a:avLst/>
+          </a:prstGeom>
+          <a:solidFill>
+            <a:schemeClr val="accent3"/>
+          </a:solidFill>
+        </p:spPr>
+        <p:style>
+          <a:lnRef idx="2">
+            <a:schemeClr val="dk1">
+              <a:shade val="50000"/>
+            </a:schemeClr>
+          </a:lnRef>
+          <a:fillRef idx="1">
+            <a:schemeClr val="dk1"/>
+          </a:fillRef>
+          <a:effectRef idx="0">
+            <a:schemeClr val="dk1"/>
+          </a:effectRef>
+          <a:fontRef idx="minor">
+            <a:schemeClr val="lt1"/>
+          </a:fontRef>
+        </p:style>
+        <p:txBody>
+          <a:bodyPr rtlCol="0" anchor="ctr"/>
+          <a:lstStyle/>
+          <a:p>
+            <a:pPr algn="ctr"/>
+            <a:endParaRPr lang="ko-KR" altLang="en-US"/>
+          </a:p>
+        </p:txBody>
+      </p:sp>
+      <p:sp>
+        <p:nvSpPr>
+          <p:cNvPr id="21" name="직사각형 20">
+            <a:extLst>
+              <a:ext uri="{FF2B5EF4-FFF2-40B4-BE49-F238E27FC236}">
+                <a16:creationId xmlns:a16="http://schemas.microsoft.com/office/drawing/2014/main" id="{E946D2E6-5BB2-4302-B3BE-C5C102292BD9}"/>
+              </a:ext>
+            </a:extLst>
+          </p:cNvPr>
+          <p:cNvSpPr/>
+          <p:nvPr/>
+        </p:nvSpPr>
+        <p:spPr>
+          <a:xfrm>
+            <a:off x="9118566" y="1576210"/>
+            <a:ext cx="1513556" cy="1995311"/>
+          </a:xfrm>
+          <a:prstGeom prst="rect">
+            <a:avLst/>
+          </a:prstGeom>
+        </p:spPr>
+        <p:style>
+          <a:lnRef idx="2">
+            <a:schemeClr val="accent1">
+              <a:shade val="50000"/>
+            </a:schemeClr>
+          </a:lnRef>
+          <a:fillRef idx="1">
+            <a:schemeClr val="accent1"/>
+          </a:fillRef>
+          <a:effectRef idx="0">
+            <a:schemeClr val="accent1"/>
+          </a:effectRef>
+          <a:fontRef idx="minor">
+            <a:schemeClr val="lt1"/>
+          </a:fontRef>
+        </p:style>
+        <p:txBody>
+          <a:bodyPr rtlCol="0" anchor="ctr"/>
+          <a:lstStyle/>
+          <a:p>
+            <a:pPr algn="ctr"/>
+            <a:r>
+              <a:rPr lang="ko-KR" altLang="en-US" sz="1400" dirty="0"/>
+              <a:t>완성품</a:t>
+            </a:r>
+            <a:endParaRPr lang="en-US" altLang="ko-KR" sz="1400" dirty="0"/>
+          </a:p>
+          <a:p>
+            <a:pPr algn="ctr"/>
+            <a:r>
+              <a:rPr lang="ko-KR" altLang="en-US" sz="1400" dirty="0"/>
+              <a:t>적재함</a:t>
+            </a:r>
+            <a:endParaRPr lang="ko-KR" altLang="en-US" dirty="0"/>
+          </a:p>
+        </p:txBody>
+      </p:sp>
+      <p:sp>
+        <p:nvSpPr>
+          <p:cNvPr id="8" name="직사각형 7">
+            <a:extLst>
+              <a:ext uri="{FF2B5EF4-FFF2-40B4-BE49-F238E27FC236}">
+                <a16:creationId xmlns:a16="http://schemas.microsoft.com/office/drawing/2014/main" id="{CF4E7BF6-ED3B-42E6-BE91-1CAD50F5F6C3}"/>
+              </a:ext>
+            </a:extLst>
+          </p:cNvPr>
+          <p:cNvSpPr/>
+          <p:nvPr/>
+        </p:nvSpPr>
+        <p:spPr>
+          <a:xfrm>
+            <a:off x="5085257" y="3954638"/>
+            <a:ext cx="2043289" cy="948267"/>
+          </a:xfrm>
+          <a:prstGeom prst="rect">
+            <a:avLst/>
+          </a:prstGeom>
+        </p:spPr>
+        <p:style>
+          <a:lnRef idx="2">
+            <a:schemeClr val="accent1">
+              <a:shade val="50000"/>
+            </a:schemeClr>
+          </a:lnRef>
+          <a:fillRef idx="1">
+            <a:schemeClr val="accent1"/>
+          </a:fillRef>
+          <a:effectRef idx="0">
+            <a:schemeClr val="accent1"/>
+          </a:effectRef>
+          <a:fontRef idx="minor">
+            <a:schemeClr val="lt1"/>
+          </a:fontRef>
+        </p:style>
+        <p:txBody>
+          <a:bodyPr rtlCol="0" anchor="ctr"/>
+          <a:lstStyle/>
+          <a:p>
+            <a:pPr algn="ctr"/>
+            <a:r>
+              <a:rPr lang="ko-KR" altLang="en-US" sz="1400" dirty="0"/>
+              <a:t>작업자</a:t>
+            </a:r>
+            <a:endParaRPr lang="en-US" altLang="ko-KR" sz="1400" dirty="0"/>
+          </a:p>
+          <a:p>
+            <a:pPr algn="ctr"/>
+            <a:r>
+              <a:rPr lang="ko-KR" altLang="en-US" sz="1400" dirty="0"/>
+              <a:t>작업 공간</a:t>
+            </a:r>
+          </a:p>
+        </p:txBody>
+      </p:sp>
+      <p:sp>
+        <p:nvSpPr>
+          <p:cNvPr id="22" name="직사각형 21">
+            <a:extLst>
+              <a:ext uri="{FF2B5EF4-FFF2-40B4-BE49-F238E27FC236}">
+                <a16:creationId xmlns:a16="http://schemas.microsoft.com/office/drawing/2014/main" id="{B6272C13-9B89-49F4-88E4-F7ED31D41781}"/>
+              </a:ext>
+            </a:extLst>
+          </p:cNvPr>
+          <p:cNvSpPr/>
+          <p:nvPr/>
+        </p:nvSpPr>
+        <p:spPr>
+          <a:xfrm>
+            <a:off x="7376901" y="3954638"/>
+            <a:ext cx="1501423" cy="948267"/>
+          </a:xfrm>
+          <a:prstGeom prst="rect">
+            <a:avLst/>
+          </a:prstGeom>
+        </p:spPr>
+        <p:style>
+          <a:lnRef idx="2">
+            <a:schemeClr val="accent1">
+              <a:shade val="50000"/>
+            </a:schemeClr>
+          </a:lnRef>
+          <a:fillRef idx="1">
+            <a:schemeClr val="accent1"/>
+          </a:fillRef>
+          <a:effectRef idx="0">
+            <a:schemeClr val="accent1"/>
+          </a:effectRef>
+          <a:fontRef idx="minor">
+            <a:schemeClr val="lt1"/>
+          </a:fontRef>
+        </p:style>
+        <p:txBody>
+          <a:bodyPr rtlCol="0" anchor="ctr"/>
+          <a:lstStyle/>
+          <a:p>
+            <a:pPr algn="ctr"/>
+            <a:r>
+              <a:rPr lang="ko-KR" altLang="en-US" sz="1400"/>
+              <a:t>검수 공간</a:t>
+            </a:r>
+            <a:endParaRPr lang="ko-KR" altLang="en-US" sz="1400" dirty="0"/>
+          </a:p>
+        </p:txBody>
+      </p:sp>
+      <p:sp>
+        <p:nvSpPr>
+          <p:cNvPr id="23" name="직사각형 22">
+            <a:extLst>
+              <a:ext uri="{FF2B5EF4-FFF2-40B4-BE49-F238E27FC236}">
+                <a16:creationId xmlns:a16="http://schemas.microsoft.com/office/drawing/2014/main" id="{ED3DCDA5-AE1F-4AFD-AEF4-7A4280B65580}"/>
+              </a:ext>
+            </a:extLst>
+          </p:cNvPr>
+          <p:cNvSpPr/>
+          <p:nvPr/>
+        </p:nvSpPr>
+        <p:spPr>
+          <a:xfrm>
+            <a:off x="3335479" y="3954637"/>
+            <a:ext cx="1501423" cy="948267"/>
+          </a:xfrm>
+          <a:prstGeom prst="rect">
+            <a:avLst/>
+          </a:prstGeom>
+        </p:spPr>
+        <p:style>
+          <a:lnRef idx="2">
+            <a:schemeClr val="accent1">
+              <a:shade val="50000"/>
+            </a:schemeClr>
+          </a:lnRef>
+          <a:fillRef idx="1">
+            <a:schemeClr val="accent1"/>
+          </a:fillRef>
+          <a:effectRef idx="0">
+            <a:schemeClr val="accent1"/>
+          </a:effectRef>
+          <a:fontRef idx="minor">
+            <a:schemeClr val="lt1"/>
+          </a:fontRef>
+        </p:style>
+        <p:txBody>
+          <a:bodyPr rtlCol="0" anchor="ctr"/>
+          <a:lstStyle/>
+          <a:p>
+            <a:pPr algn="ctr"/>
+            <a:r>
+              <a:rPr lang="ko-KR" altLang="en-US" sz="1400" dirty="0"/>
+              <a:t>부품 대기 공간</a:t>
+            </a:r>
+          </a:p>
+        </p:txBody>
+      </p:sp>
+      <p:sp>
+        <p:nvSpPr>
+          <p:cNvPr id="24" name="직사각형 23">
+            <a:extLst>
+              <a:ext uri="{FF2B5EF4-FFF2-40B4-BE49-F238E27FC236}">
+                <a16:creationId xmlns:a16="http://schemas.microsoft.com/office/drawing/2014/main" id="{50BA44A8-C47B-42C4-88C1-8650FCF7AB99}"/>
+              </a:ext>
+            </a:extLst>
+          </p:cNvPr>
+          <p:cNvSpPr/>
+          <p:nvPr/>
+        </p:nvSpPr>
+        <p:spPr>
+          <a:xfrm>
+            <a:off x="5666634" y="1576210"/>
+            <a:ext cx="880533" cy="1995311"/>
+          </a:xfrm>
+          <a:prstGeom prst="rect">
+            <a:avLst/>
+          </a:prstGeom>
+        </p:spPr>
+        <p:style>
+          <a:lnRef idx="2">
+            <a:schemeClr val="accent1">
+              <a:shade val="50000"/>
+            </a:schemeClr>
+          </a:lnRef>
+          <a:fillRef idx="1">
+            <a:schemeClr val="accent1"/>
+          </a:fillRef>
+          <a:effectRef idx="0">
+            <a:schemeClr val="accent1"/>
+          </a:effectRef>
+          <a:fontRef idx="minor">
+            <a:schemeClr val="lt1"/>
+          </a:fontRef>
+        </p:style>
+        <p:txBody>
+          <a:bodyPr rtlCol="0" anchor="ctr"/>
+          <a:lstStyle/>
+          <a:p>
+            <a:pPr algn="ctr"/>
+            <a:r>
+              <a:rPr lang="ko-KR" altLang="en-US" sz="1400" dirty="0"/>
+              <a:t>불량품</a:t>
+            </a:r>
+            <a:endParaRPr lang="en-US" altLang="ko-KR" sz="1400" dirty="0"/>
+          </a:p>
+          <a:p>
+            <a:pPr algn="ctr"/>
+            <a:r>
+              <a:rPr lang="ko-KR" altLang="en-US" sz="1400" dirty="0"/>
+              <a:t>적재함</a:t>
+            </a:r>
+            <a:endParaRPr lang="ko-KR" altLang="en-US" dirty="0"/>
+          </a:p>
+        </p:txBody>
+      </p:sp>
+      <p:sp>
+        <p:nvSpPr>
+          <p:cNvPr id="25" name="타원 24">
+            <a:extLst>
+              <a:ext uri="{FF2B5EF4-FFF2-40B4-BE49-F238E27FC236}">
+                <a16:creationId xmlns:a16="http://schemas.microsoft.com/office/drawing/2014/main" id="{2CA188E0-9D72-4F55-8CBF-A387D94E03F7}"/>
+              </a:ext>
+            </a:extLst>
+          </p:cNvPr>
+          <p:cNvSpPr/>
+          <p:nvPr/>
+        </p:nvSpPr>
+        <p:spPr>
+          <a:xfrm>
+            <a:off x="5759596" y="5286023"/>
+            <a:ext cx="672031" cy="609135"/>
+          </a:xfrm>
+          <a:prstGeom prst="ellipse">
+            <a:avLst/>
+          </a:prstGeom>
+          <a:solidFill>
+            <a:srgbClr val="7030A0"/>
+          </a:solidFill>
+        </p:spPr>
+        <p:style>
+          <a:lnRef idx="2">
+            <a:schemeClr val="accent1">
+              <a:shade val="50000"/>
+            </a:schemeClr>
+          </a:lnRef>
+          <a:fillRef idx="1">
+            <a:schemeClr val="accent1"/>
+          </a:fillRef>
+          <a:effectRef idx="0">
+            <a:schemeClr val="accent1"/>
+          </a:effectRef>
+          <a:fontRef idx="minor">
+            <a:schemeClr val="lt1"/>
+          </a:fontRef>
+        </p:style>
+        <p:txBody>
+          <a:bodyPr rtlCol="0" anchor="ctr"/>
+          <a:lstStyle/>
+          <a:p>
+            <a:pPr algn="ctr"/>
+            <a:r>
+              <a:rPr lang="ko-KR" altLang="en-US" sz="1200" dirty="0"/>
+              <a:t>작업자</a:t>
+            </a:r>
+          </a:p>
+        </p:txBody>
+      </p:sp>
+      <p:sp>
+        <p:nvSpPr>
+          <p:cNvPr id="26" name="TextBox 25">
+            <a:extLst>
+              <a:ext uri="{FF2B5EF4-FFF2-40B4-BE49-F238E27FC236}">
+                <a16:creationId xmlns:a16="http://schemas.microsoft.com/office/drawing/2014/main" id="{44517D35-A087-411C-BA94-97B99C6409BE}"/>
+              </a:ext>
+            </a:extLst>
+          </p:cNvPr>
+          <p:cNvSpPr txBox="1"/>
+          <p:nvPr/>
+        </p:nvSpPr>
+        <p:spPr>
+          <a:xfrm>
+            <a:off x="5339222" y="593510"/>
+            <a:ext cx="1513556" cy="369332"/>
+          </a:xfrm>
+          <a:prstGeom prst="rect">
+            <a:avLst/>
+          </a:prstGeom>
+          <a:noFill/>
+        </p:spPr>
+        <p:txBody>
+          <a:bodyPr wrap="none" rtlCol="0">
+            <a:spAutoFit/>
+          </a:bodyPr>
+          <a:lstStyle/>
+          <a:p>
+            <a:r>
+              <a:rPr lang="en-US" altLang="ko-KR" dirty="0"/>
+              <a:t>&lt;</a:t>
+            </a:r>
+            <a:r>
+              <a:rPr lang="ko-KR" altLang="en-US" dirty="0"/>
+              <a:t>작업 공간</a:t>
+            </a:r>
+            <a:r>
+              <a:rPr lang="en-US" altLang="ko-KR" dirty="0"/>
+              <a:t>&gt;</a:t>
+            </a:r>
+            <a:endParaRPr lang="ko-KR" altLang="en-US" dirty="0"/>
+          </a:p>
+        </p:txBody>
+      </p:sp>
+    </p:spTree>
+    <p:extLst>
+      <p:ext uri="{BB962C8B-B14F-4D97-AF65-F5344CB8AC3E}">
+        <p14:creationId xmlns:p14="http://schemas.microsoft.com/office/powerpoint/2010/main" val="2386937432"/>
+      </p:ext>
+    </p:extLst>
+  </p:cSld>
+  <p:clrMapOvr>
+    <a:masterClrMapping/>
+  </p:clrMapOvr>
+</p:sld>
+</file>
+
+<file path=ppt/slides/slide2.xml><?xml version="1.0" encoding="utf-8"?>
+<p:sld xmlns:a="http://schemas.openxmlformats.org/drawingml/2006/main" xmlns:r="http://schemas.openxmlformats.org/officeDocument/2006/relationships" xmlns:p="http://schemas.openxmlformats.org/presentationml/2006/main">
+  <p:cSld>
+    <p:spTree>
+      <p:nvGrpSpPr>
+        <p:cNvPr id="1" name=""/>
+        <p:cNvGrpSpPr/>
+        <p:nvPr/>
+      </p:nvGrpSpPr>
+      <p:grpSpPr>
+        <a:xfrm>
+          <a:off x="0" y="0"/>
+          <a:ext cx="0" cy="0"/>
+          <a:chOff x="0" y="0"/>
+          <a:chExt cx="0" cy="0"/>
+        </a:xfrm>
+      </p:grpSpPr>
       <p:grpSp>
         <p:nvGrpSpPr>
-          <p:cNvPr id="27" name="그룹 26">
-            <a:extLst>
-              <a:ext uri="{FF2B5EF4-FFF2-40B4-BE49-F238E27FC236}">
-                <a16:creationId xmlns:a16="http://schemas.microsoft.com/office/drawing/2014/main" id="{546425DD-1992-4E06-8471-4BB639D09BD1}"/>
+          <p:cNvPr id="28" name="그룹 27">
+            <a:extLst>
+              <a:ext uri="{FF2B5EF4-FFF2-40B4-BE49-F238E27FC236}">
+                <a16:creationId xmlns:a16="http://schemas.microsoft.com/office/drawing/2014/main" id="{5FF70482-C2FA-42BF-B604-AA91996015E0}"/>
               </a:ext>
             </a:extLst>
           </p:cNvPr>
@@ -3341,10 +3954,10 @@
         </p:nvGrpSpPr>
         <p:grpSpPr>
           <a:xfrm>
-            <a:off x="1559878" y="1576210"/>
-            <a:ext cx="9072244" cy="4318948"/>
-            <a:chOff x="1769111" y="1576210"/>
-            <a:chExt cx="9072244" cy="4318948"/>
+            <a:off x="1676824" y="425170"/>
+            <a:ext cx="8838353" cy="6007660"/>
+            <a:chOff x="1676824" y="425170"/>
+            <a:chExt cx="8838353" cy="6007660"/>
           </a:xfrm>
         </p:grpSpPr>
         <p:sp>
@@ -3352,7 +3965,7 @@
             <p:cNvPr id="2" name="직사각형 1">
               <a:extLst>
                 <a:ext uri="{FF2B5EF4-FFF2-40B4-BE49-F238E27FC236}">
-                  <a16:creationId xmlns:a16="http://schemas.microsoft.com/office/drawing/2014/main" id="{E74C06BE-6EAF-481A-884E-1E685522BEF6}"/>
+                  <a16:creationId xmlns:a16="http://schemas.microsoft.com/office/drawing/2014/main" id="{CF8448D8-C608-46EE-BDB8-D4C6724B617A}"/>
                 </a:ext>
               </a:extLst>
             </p:cNvPr>
@@ -3361,8 +3974,57 @@
           </p:nvSpPr>
           <p:spPr>
             <a:xfrm>
-              <a:off x="1769111" y="1576211"/>
-              <a:ext cx="1513556" cy="1995311"/>
+              <a:off x="4859867" y="1596723"/>
+              <a:ext cx="2472267" cy="3668678"/>
+            </a:xfrm>
+            <a:prstGeom prst="rect">
+              <a:avLst/>
+            </a:prstGeom>
+            <a:solidFill>
+              <a:schemeClr val="accent3"/>
+            </a:solidFill>
+          </p:spPr>
+          <p:style>
+            <a:lnRef idx="2">
+              <a:schemeClr val="dk1">
+                <a:shade val="50000"/>
+              </a:schemeClr>
+            </a:lnRef>
+            <a:fillRef idx="1">
+              <a:schemeClr val="dk1"/>
+            </a:fillRef>
+            <a:effectRef idx="0">
+              <a:schemeClr val="dk1"/>
+            </a:effectRef>
+            <a:fontRef idx="minor">
+              <a:schemeClr val="lt1"/>
+            </a:fontRef>
+          </p:style>
+          <p:txBody>
+            <a:bodyPr rtlCol="0" anchor="ctr"/>
+            <a:lstStyle/>
+            <a:p>
+              <a:pPr algn="ctr"/>
+              <a:endParaRPr lang="ko-KR" altLang="en-US"/>
+            </a:p>
+          </p:txBody>
+        </p:sp>
+        <p:sp>
+          <p:nvSpPr>
+            <p:cNvPr id="3" name="직사각형 2">
+              <a:extLst>
+                <a:ext uri="{FF2B5EF4-FFF2-40B4-BE49-F238E27FC236}">
+                  <a16:creationId xmlns:a16="http://schemas.microsoft.com/office/drawing/2014/main" id="{0BEF9CAA-8102-4DDB-88E4-AA85580835B6}"/>
+                </a:ext>
+              </a:extLst>
+            </p:cNvPr>
+            <p:cNvSpPr/>
+            <p:nvPr/>
+          </p:nvSpPr>
+          <p:spPr>
+            <a:xfrm>
+              <a:off x="4978401" y="1693333"/>
+              <a:ext cx="2269066" cy="3454399"/>
             </a:xfrm>
             <a:prstGeom prst="rect">
               <a:avLst/>
@@ -3391,7 +4053,7 @@
               <a:pPr algn="ctr"/>
               <a:r>
                 <a:rPr lang="ko-KR" altLang="en-US" sz="1400" dirty="0"/>
-                <a:t>부품</a:t>
+                <a:t>물류 분류</a:t>
               </a:r>
               <a:endParaRPr lang="en-US" altLang="ko-KR" sz="1400" dirty="0"/>
             </a:p>
@@ -3399,18 +4061,17 @@
               <a:pPr algn="ctr"/>
               <a:r>
                 <a:rPr lang="ko-KR" altLang="en-US" sz="1400" dirty="0"/>
-                <a:t>적재함</a:t>
+                <a:t>작업대</a:t>
               </a:r>
-              <a:endParaRPr lang="ko-KR" altLang="en-US" dirty="0"/>
             </a:p>
           </p:txBody>
         </p:sp>
         <p:sp>
           <p:nvSpPr>
-            <p:cNvPr id="3" name="타원 2">
+            <p:cNvPr id="4" name="타원 3">
               <a:extLst>
                 <a:ext uri="{FF2B5EF4-FFF2-40B4-BE49-F238E27FC236}">
-                  <a16:creationId xmlns:a16="http://schemas.microsoft.com/office/drawing/2014/main" id="{E4600936-A723-4262-9187-DBE37F6CA8D0}"/>
+                  <a16:creationId xmlns:a16="http://schemas.microsoft.com/office/drawing/2014/main" id="{B0925292-A059-462E-9ADC-65A62447B952}"/>
                 </a:ext>
               </a:extLst>
             </p:cNvPr>
@@ -3419,12 +4080,15 @@
           </p:nvSpPr>
           <p:spPr>
             <a:xfrm>
-              <a:off x="4139000" y="2349151"/>
+              <a:off x="3584857" y="2985029"/>
               <a:ext cx="880533" cy="869244"/>
             </a:xfrm>
             <a:prstGeom prst="ellipse">
               <a:avLst/>
             </a:prstGeom>
+            <a:solidFill>
+              <a:schemeClr val="tx1"/>
+            </a:solidFill>
           </p:spPr>
           <p:style>
             <a:lnRef idx="2">
@@ -3461,10 +4125,10 @@
         </p:sp>
         <p:sp>
           <p:nvSpPr>
-            <p:cNvPr id="20" name="타원 19">
+            <p:cNvPr id="5" name="타원 4">
               <a:extLst>
                 <a:ext uri="{FF2B5EF4-FFF2-40B4-BE49-F238E27FC236}">
-                  <a16:creationId xmlns:a16="http://schemas.microsoft.com/office/drawing/2014/main" id="{84ACEA36-FD47-458B-980C-D3E08139C069}"/>
+                  <a16:creationId xmlns:a16="http://schemas.microsoft.com/office/drawing/2014/main" id="{5B09F982-8DB7-4391-AA41-C8A7EB607577}"/>
                 </a:ext>
               </a:extLst>
             </p:cNvPr>
@@ -3473,12 +4137,15 @@
           </p:nvSpPr>
           <p:spPr>
             <a:xfrm>
-              <a:off x="7612733" y="2349151"/>
+              <a:off x="7726611" y="2985029"/>
               <a:ext cx="880533" cy="869244"/>
             </a:xfrm>
             <a:prstGeom prst="ellipse">
               <a:avLst/>
             </a:prstGeom>
+            <a:solidFill>
+              <a:schemeClr val="tx1"/>
+            </a:solidFill>
           </p:spPr>
           <p:style>
             <a:lnRef idx="2">
@@ -3515,10 +4182,10 @@
         </p:sp>
         <p:sp>
           <p:nvSpPr>
-            <p:cNvPr id="5" name="직사각형 4">
+            <p:cNvPr id="6" name="직사각형 5">
               <a:extLst>
                 <a:ext uri="{FF2B5EF4-FFF2-40B4-BE49-F238E27FC236}">
-                  <a16:creationId xmlns:a16="http://schemas.microsoft.com/office/drawing/2014/main" id="{4CD68C48-AD1A-4C41-A802-027542CB4067}"/>
+                  <a16:creationId xmlns:a16="http://schemas.microsoft.com/office/drawing/2014/main" id="{8EFC95D9-1D12-4CF8-9006-CA0C00933F16}"/>
                 </a:ext>
               </a:extLst>
             </p:cNvPr>
@@ -3527,57 +4194,8 @@
           </p:nvSpPr>
           <p:spPr>
             <a:xfrm>
-              <a:off x="3282667" y="3753557"/>
-              <a:ext cx="6045132" cy="1350431"/>
-            </a:xfrm>
-            <a:prstGeom prst="rect">
-              <a:avLst/>
-            </a:prstGeom>
-            <a:solidFill>
-              <a:schemeClr val="accent3"/>
-            </a:solidFill>
-          </p:spPr>
-          <p:style>
-            <a:lnRef idx="2">
-              <a:schemeClr val="dk1">
-                <a:shade val="50000"/>
-              </a:schemeClr>
-            </a:lnRef>
-            <a:fillRef idx="1">
-              <a:schemeClr val="dk1"/>
-            </a:fillRef>
-            <a:effectRef idx="0">
-              <a:schemeClr val="dk1"/>
-            </a:effectRef>
-            <a:fontRef idx="minor">
-              <a:schemeClr val="lt1"/>
-            </a:fontRef>
-          </p:style>
-          <p:txBody>
-            <a:bodyPr rtlCol="0" anchor="ctr"/>
-            <a:lstStyle/>
-            <a:p>
-              <a:pPr algn="ctr"/>
-              <a:endParaRPr lang="ko-KR" altLang="en-US"/>
-            </a:p>
-          </p:txBody>
-        </p:sp>
-        <p:sp>
-          <p:nvSpPr>
-            <p:cNvPr id="21" name="직사각형 20">
-              <a:extLst>
-                <a:ext uri="{FF2B5EF4-FFF2-40B4-BE49-F238E27FC236}">
-                  <a16:creationId xmlns:a16="http://schemas.microsoft.com/office/drawing/2014/main" id="{E946D2E6-5BB2-4302-B3BE-C5C102292BD9}"/>
-                </a:ext>
-              </a:extLst>
-            </p:cNvPr>
-            <p:cNvSpPr/>
-            <p:nvPr/>
-          </p:nvSpPr>
-          <p:spPr>
-            <a:xfrm>
-              <a:off x="9327799" y="1576210"/>
-              <a:ext cx="1513556" cy="1995311"/>
+              <a:off x="1676824" y="1016528"/>
+              <a:ext cx="1513556" cy="1381480"/>
             </a:xfrm>
             <a:prstGeom prst="rect">
               <a:avLst/>
@@ -3606,9 +4224,12 @@
               <a:pPr algn="ctr"/>
               <a:r>
                 <a:rPr lang="ko-KR" altLang="en-US" sz="1400" dirty="0"/>
-                <a:t>완성품</a:t>
+                <a:t>물류</a:t>
               </a:r>
-              <a:endParaRPr lang="en-US" altLang="ko-KR" sz="1400" dirty="0"/>
+              <a:r>
+                <a:rPr lang="en-US" altLang="ko-KR" sz="1400" dirty="0"/>
+                <a:t>A-Red</a:t>
+              </a:r>
             </a:p>
             <a:p>
               <a:pPr algn="ctr"/>
@@ -3622,10 +4243,10 @@
         </p:sp>
         <p:sp>
           <p:nvSpPr>
-            <p:cNvPr id="8" name="직사각형 7">
+            <p:cNvPr id="7" name="직사각형 6">
               <a:extLst>
                 <a:ext uri="{FF2B5EF4-FFF2-40B4-BE49-F238E27FC236}">
-                  <a16:creationId xmlns:a16="http://schemas.microsoft.com/office/drawing/2014/main" id="{CF4E7BF6-ED3B-42E6-BE91-1CAD50F5F6C3}"/>
+                  <a16:creationId xmlns:a16="http://schemas.microsoft.com/office/drawing/2014/main" id="{9C0AB604-7E72-4B16-A736-97EEF8FBA31F}"/>
                 </a:ext>
               </a:extLst>
             </p:cNvPr>
@@ -3634,8 +4255,8 @@
           </p:nvSpPr>
           <p:spPr>
             <a:xfrm>
-              <a:off x="5294490" y="3954638"/>
-              <a:ext cx="2043289" cy="948267"/>
+              <a:off x="9001621" y="1016528"/>
+              <a:ext cx="1513556" cy="1381479"/>
             </a:xfrm>
             <a:prstGeom prst="rect">
               <a:avLst/>
@@ -3664,25 +4285,29 @@
               <a:pPr algn="ctr"/>
               <a:r>
                 <a:rPr lang="ko-KR" altLang="en-US" sz="1400" dirty="0"/>
-                <a:t>작업자</a:t>
+                <a:t>물류</a:t>
               </a:r>
-              <a:endParaRPr lang="en-US" altLang="ko-KR" sz="1400" dirty="0"/>
+              <a:r>
+                <a:rPr lang="en-US" altLang="ko-KR" sz="1400" dirty="0"/>
+                <a:t>A-Green</a:t>
+              </a:r>
             </a:p>
             <a:p>
               <a:pPr algn="ctr"/>
               <a:r>
                 <a:rPr lang="ko-KR" altLang="en-US" sz="1400" dirty="0"/>
-                <a:t>작업 공간</a:t>
+                <a:t>적재함</a:t>
               </a:r>
+              <a:endParaRPr lang="ko-KR" altLang="en-US" dirty="0"/>
             </a:p>
           </p:txBody>
         </p:sp>
         <p:sp>
           <p:nvSpPr>
-            <p:cNvPr id="22" name="직사각형 21">
+            <p:cNvPr id="8" name="직사각형 7">
               <a:extLst>
                 <a:ext uri="{FF2B5EF4-FFF2-40B4-BE49-F238E27FC236}">
-                  <a16:creationId xmlns:a16="http://schemas.microsoft.com/office/drawing/2014/main" id="{B6272C13-9B89-49F4-88E4-F7ED31D41781}"/>
+                  <a16:creationId xmlns:a16="http://schemas.microsoft.com/office/drawing/2014/main" id="{1847B8CE-3815-4B82-9F6C-75A54E1444F3}"/>
                 </a:ext>
               </a:extLst>
             </p:cNvPr>
@@ -3691,58 +4316,8 @@
           </p:nvSpPr>
           <p:spPr>
             <a:xfrm>
-              <a:off x="7586134" y="3954638"/>
-              <a:ext cx="1501423" cy="948267"/>
-            </a:xfrm>
-            <a:prstGeom prst="rect">
-              <a:avLst/>
-            </a:prstGeom>
-          </p:spPr>
-          <p:style>
-            <a:lnRef idx="2">
-              <a:schemeClr val="accent1">
-                <a:shade val="50000"/>
-              </a:schemeClr>
-            </a:lnRef>
-            <a:fillRef idx="1">
-              <a:schemeClr val="accent1"/>
-            </a:fillRef>
-            <a:effectRef idx="0">
-              <a:schemeClr val="accent1"/>
-            </a:effectRef>
-            <a:fontRef idx="minor">
-              <a:schemeClr val="lt1"/>
-            </a:fontRef>
-          </p:style>
-          <p:txBody>
-            <a:bodyPr rtlCol="0" anchor="ctr"/>
-            <a:lstStyle/>
-            <a:p>
-              <a:pPr algn="ctr"/>
-              <a:r>
-                <a:rPr lang="ko-KR" altLang="en-US" sz="1400"/>
-                <a:t>검수 공간</a:t>
-              </a:r>
-              <a:endParaRPr lang="ko-KR" altLang="en-US" sz="1400" dirty="0"/>
-            </a:p>
-          </p:txBody>
-        </p:sp>
-        <p:sp>
-          <p:nvSpPr>
-            <p:cNvPr id="23" name="직사각형 22">
-              <a:extLst>
-                <a:ext uri="{FF2B5EF4-FFF2-40B4-BE49-F238E27FC236}">
-                  <a16:creationId xmlns:a16="http://schemas.microsoft.com/office/drawing/2014/main" id="{ED3DCDA5-AE1F-4AFD-AEF4-7A4280B65580}"/>
-                </a:ext>
-              </a:extLst>
-            </p:cNvPr>
-            <p:cNvSpPr/>
-            <p:nvPr/>
-          </p:nvSpPr>
-          <p:spPr>
-            <a:xfrm>
-              <a:off x="3544712" y="3954637"/>
-              <a:ext cx="1501423" cy="948267"/>
+              <a:off x="1676824" y="2728911"/>
+              <a:ext cx="1513556" cy="1381480"/>
             </a:xfrm>
             <a:prstGeom prst="rect">
               <a:avLst/>
@@ -3771,17 +4346,29 @@
               <a:pPr algn="ctr"/>
               <a:r>
                 <a:rPr lang="ko-KR" altLang="en-US" sz="1400" dirty="0"/>
-                <a:t>부품 대기 공간</a:t>
+                <a:t>물류</a:t>
               </a:r>
+              <a:r>
+                <a:rPr lang="en-US" altLang="ko-KR" sz="1400" dirty="0"/>
+                <a:t>B-Blue</a:t>
+              </a:r>
+            </a:p>
+            <a:p>
+              <a:pPr algn="ctr"/>
+              <a:r>
+                <a:rPr lang="ko-KR" altLang="en-US" sz="1400" dirty="0"/>
+                <a:t>적재함</a:t>
+              </a:r>
+              <a:endParaRPr lang="ko-KR" altLang="en-US" dirty="0"/>
             </a:p>
           </p:txBody>
         </p:sp>
         <p:sp>
           <p:nvSpPr>
-            <p:cNvPr id="24" name="직사각형 23">
+            <p:cNvPr id="9" name="직사각형 8">
               <a:extLst>
                 <a:ext uri="{FF2B5EF4-FFF2-40B4-BE49-F238E27FC236}">
-                  <a16:creationId xmlns:a16="http://schemas.microsoft.com/office/drawing/2014/main" id="{50BA44A8-C47B-42C4-88C1-8650FCF7AB99}"/>
+                  <a16:creationId xmlns:a16="http://schemas.microsoft.com/office/drawing/2014/main" id="{BE08ED9D-D1E9-46C1-86BE-E4EDC3E934C1}"/>
                 </a:ext>
               </a:extLst>
             </p:cNvPr>
@@ -3790,8 +4377,8 @@
           </p:nvSpPr>
           <p:spPr>
             <a:xfrm>
-              <a:off x="5875867" y="1576210"/>
-              <a:ext cx="880533" cy="1995311"/>
+              <a:off x="9001621" y="2728911"/>
+              <a:ext cx="1513556" cy="1381480"/>
             </a:xfrm>
             <a:prstGeom prst="rect">
               <a:avLst/>
@@ -3820,7 +4407,133 @@
               <a:pPr algn="ctr"/>
               <a:r>
                 <a:rPr lang="ko-KR" altLang="en-US" sz="1400" dirty="0"/>
-                <a:t>불량품</a:t>
+                <a:t>물류</a:t>
+              </a:r>
+              <a:r>
+                <a:rPr lang="en-US" altLang="ko-KR" sz="1400" dirty="0"/>
+                <a:t>B-Red</a:t>
+              </a:r>
+            </a:p>
+            <a:p>
+              <a:pPr algn="ctr"/>
+              <a:r>
+                <a:rPr lang="ko-KR" altLang="en-US" sz="1400" dirty="0"/>
+                <a:t>적재함</a:t>
+              </a:r>
+              <a:endParaRPr lang="ko-KR" altLang="en-US" dirty="0"/>
+            </a:p>
+          </p:txBody>
+        </p:sp>
+        <p:sp>
+          <p:nvSpPr>
+            <p:cNvPr id="10" name="직사각형 9">
+              <a:extLst>
+                <a:ext uri="{FF2B5EF4-FFF2-40B4-BE49-F238E27FC236}">
+                  <a16:creationId xmlns:a16="http://schemas.microsoft.com/office/drawing/2014/main" id="{D75B7A29-F662-40E3-9C48-3CAA936A2A86}"/>
+                </a:ext>
+              </a:extLst>
+            </p:cNvPr>
+            <p:cNvSpPr/>
+            <p:nvPr/>
+          </p:nvSpPr>
+          <p:spPr>
+            <a:xfrm>
+              <a:off x="1676824" y="4441294"/>
+              <a:ext cx="1513556" cy="1381480"/>
+            </a:xfrm>
+            <a:prstGeom prst="rect">
+              <a:avLst/>
+            </a:prstGeom>
+          </p:spPr>
+          <p:style>
+            <a:lnRef idx="2">
+              <a:schemeClr val="accent1">
+                <a:shade val="50000"/>
+              </a:schemeClr>
+            </a:lnRef>
+            <a:fillRef idx="1">
+              <a:schemeClr val="accent1"/>
+            </a:fillRef>
+            <a:effectRef idx="0">
+              <a:schemeClr val="accent1"/>
+            </a:effectRef>
+            <a:fontRef idx="minor">
+              <a:schemeClr val="lt1"/>
+            </a:fontRef>
+          </p:style>
+          <p:txBody>
+            <a:bodyPr rtlCol="0" anchor="ctr"/>
+            <a:lstStyle/>
+            <a:p>
+              <a:pPr algn="ctr"/>
+              <a:r>
+                <a:rPr lang="ko-KR" altLang="en-US" sz="1400" dirty="0"/>
+                <a:t>물류</a:t>
+              </a:r>
+              <a:r>
+                <a:rPr lang="en-US" altLang="ko-KR" sz="1400" dirty="0"/>
+                <a:t>C-Green</a:t>
+              </a:r>
+            </a:p>
+            <a:p>
+              <a:pPr algn="ctr"/>
+              <a:r>
+                <a:rPr lang="ko-KR" altLang="en-US" sz="1400" dirty="0"/>
+                <a:t>적재함</a:t>
+              </a:r>
+              <a:endParaRPr lang="ko-KR" altLang="en-US" dirty="0"/>
+            </a:p>
+          </p:txBody>
+        </p:sp>
+        <p:sp>
+          <p:nvSpPr>
+            <p:cNvPr id="11" name="직사각형 10">
+              <a:extLst>
+                <a:ext uri="{FF2B5EF4-FFF2-40B4-BE49-F238E27FC236}">
+                  <a16:creationId xmlns:a16="http://schemas.microsoft.com/office/drawing/2014/main" id="{6E73B3D3-7DE1-4DD7-8A0F-414C7C8C41B0}"/>
+                </a:ext>
+              </a:extLst>
+            </p:cNvPr>
+            <p:cNvSpPr/>
+            <p:nvPr/>
+          </p:nvSpPr>
+          <p:spPr>
+            <a:xfrm>
+              <a:off x="9001621" y="4441294"/>
+              <a:ext cx="1513556" cy="1381480"/>
+            </a:xfrm>
+            <a:prstGeom prst="rect">
+              <a:avLst/>
+            </a:prstGeom>
+          </p:spPr>
+          <p:style>
+            <a:lnRef idx="2">
+              <a:schemeClr val="accent1">
+                <a:shade val="50000"/>
+              </a:schemeClr>
+            </a:lnRef>
+            <a:fillRef idx="1">
+              <a:schemeClr val="accent1"/>
+            </a:fillRef>
+            <a:effectRef idx="0">
+              <a:schemeClr val="accent1"/>
+            </a:effectRef>
+            <a:fontRef idx="minor">
+              <a:schemeClr val="lt1"/>
+            </a:fontRef>
+          </p:style>
+          <p:txBody>
+            <a:bodyPr rtlCol="0" anchor="ctr"/>
+            <a:lstStyle/>
+            <a:p>
+              <a:pPr algn="ctr"/>
+              <a:r>
+                <a:rPr lang="ko-KR" altLang="en-US" sz="1400" dirty="0"/>
+                <a:t>물류</a:t>
+              </a:r>
+              <a:r>
+                <a:rPr lang="en-US" altLang="ko-KR" sz="1400"/>
+                <a:t>C-Blue</a:t>
               </a:r>
               <a:endParaRPr lang="en-US" altLang="ko-KR" sz="1400" dirty="0"/>
             </a:p>
@@ -3836,10 +4549,10 @@
         </p:sp>
         <p:sp>
           <p:nvSpPr>
-            <p:cNvPr id="25" name="타원 24">
+            <p:cNvPr id="12" name="타원 11">
               <a:extLst>
                 <a:ext uri="{FF2B5EF4-FFF2-40B4-BE49-F238E27FC236}">
-                  <a16:creationId xmlns:a16="http://schemas.microsoft.com/office/drawing/2014/main" id="{2CA188E0-9D72-4F55-8CBF-A387D94E03F7}"/>
+                  <a16:creationId xmlns:a16="http://schemas.microsoft.com/office/drawing/2014/main" id="{8D6DB087-A029-40EF-AF34-D805DDBA8F57}"/>
                 </a:ext>
               </a:extLst>
             </p:cNvPr>
@@ -3848,7 +4561,7 @@
           </p:nvSpPr>
           <p:spPr>
             <a:xfrm>
-              <a:off x="5968829" y="5286023"/>
+              <a:off x="5759985" y="5518206"/>
               <a:ext cx="672031" cy="609135"/>
             </a:xfrm>
             <a:prstGeom prst="ellipse">
@@ -3886,81 +4599,625 @@
             </a:p>
           </p:txBody>
         </p:sp>
+        <p:sp>
+          <p:nvSpPr>
+            <p:cNvPr id="13" name="타원 12">
+              <a:extLst>
+                <a:ext uri="{FF2B5EF4-FFF2-40B4-BE49-F238E27FC236}">
+                  <a16:creationId xmlns:a16="http://schemas.microsoft.com/office/drawing/2014/main" id="{03370E80-8C76-4D20-9ACD-DF3EE6071BF4}"/>
+                </a:ext>
+              </a:extLst>
+            </p:cNvPr>
+            <p:cNvSpPr/>
+            <p:nvPr/>
+          </p:nvSpPr>
+          <p:spPr>
+            <a:xfrm>
+              <a:off x="5759985" y="711960"/>
+              <a:ext cx="672031" cy="609135"/>
+            </a:xfrm>
+            <a:prstGeom prst="ellipse">
+              <a:avLst/>
+            </a:prstGeom>
+            <a:solidFill>
+              <a:srgbClr val="7030A0"/>
+            </a:solidFill>
+          </p:spPr>
+          <p:style>
+            <a:lnRef idx="2">
+              <a:schemeClr val="accent1">
+                <a:shade val="50000"/>
+              </a:schemeClr>
+            </a:lnRef>
+            <a:fillRef idx="1">
+              <a:schemeClr val="accent1"/>
+            </a:fillRef>
+            <a:effectRef idx="0">
+              <a:schemeClr val="accent1"/>
+            </a:effectRef>
+            <a:fontRef idx="minor">
+              <a:schemeClr val="lt1"/>
+            </a:fontRef>
+          </p:style>
+          <p:txBody>
+            <a:bodyPr rtlCol="0" anchor="ctr"/>
+            <a:lstStyle/>
+            <a:p>
+              <a:pPr algn="ctr"/>
+              <a:r>
+                <a:rPr lang="ko-KR" altLang="en-US" sz="1200" dirty="0"/>
+                <a:t>작업자</a:t>
+              </a:r>
+            </a:p>
+          </p:txBody>
+        </p:sp>
+        <p:sp>
+          <p:nvSpPr>
+            <p:cNvPr id="14" name="화살표: 아래쪽 13">
+              <a:extLst>
+                <a:ext uri="{FF2B5EF4-FFF2-40B4-BE49-F238E27FC236}">
+                  <a16:creationId xmlns:a16="http://schemas.microsoft.com/office/drawing/2014/main" id="{A160A4D5-0ED3-4F3F-AC32-7335DB7B53CE}"/>
+                </a:ext>
+              </a:extLst>
+            </p:cNvPr>
+            <p:cNvSpPr/>
+            <p:nvPr/>
+          </p:nvSpPr>
+          <p:spPr>
+            <a:xfrm>
+              <a:off x="6036731" y="1370783"/>
+              <a:ext cx="118535" cy="176252"/>
+            </a:xfrm>
+            <a:prstGeom prst="downArrow">
+              <a:avLst/>
+            </a:prstGeom>
+            <a:solidFill>
+              <a:schemeClr val="tx1"/>
+            </a:solidFill>
+          </p:spPr>
+          <p:style>
+            <a:lnRef idx="2">
+              <a:schemeClr val="accent1">
+                <a:shade val="50000"/>
+              </a:schemeClr>
+            </a:lnRef>
+            <a:fillRef idx="1">
+              <a:schemeClr val="accent1"/>
+            </a:fillRef>
+            <a:effectRef idx="0">
+              <a:schemeClr val="accent1"/>
+            </a:effectRef>
+            <a:fontRef idx="minor">
+              <a:schemeClr val="lt1"/>
+            </a:fontRef>
+          </p:style>
+          <p:txBody>
+            <a:bodyPr rtlCol="0" anchor="ctr"/>
+            <a:lstStyle/>
+            <a:p>
+              <a:pPr algn="ctr"/>
+              <a:endParaRPr lang="ko-KR" altLang="en-US"/>
+            </a:p>
+          </p:txBody>
+        </p:sp>
+        <p:sp>
+          <p:nvSpPr>
+            <p:cNvPr id="20" name="화살표: 아래쪽 19">
+              <a:extLst>
+                <a:ext uri="{FF2B5EF4-FFF2-40B4-BE49-F238E27FC236}">
+                  <a16:creationId xmlns:a16="http://schemas.microsoft.com/office/drawing/2014/main" id="{AEDDB7C9-32FB-4A38-9EEC-9AF705B5AEA3}"/>
+                </a:ext>
+              </a:extLst>
+            </p:cNvPr>
+            <p:cNvSpPr/>
+            <p:nvPr/>
+          </p:nvSpPr>
+          <p:spPr>
+            <a:xfrm rot="10800000">
+              <a:off x="6036731" y="5303677"/>
+              <a:ext cx="118535" cy="176252"/>
+            </a:xfrm>
+            <a:prstGeom prst="downArrow">
+              <a:avLst/>
+            </a:prstGeom>
+            <a:solidFill>
+              <a:schemeClr val="tx1"/>
+            </a:solidFill>
+          </p:spPr>
+          <p:style>
+            <a:lnRef idx="2">
+              <a:schemeClr val="accent1">
+                <a:shade val="50000"/>
+              </a:schemeClr>
+            </a:lnRef>
+            <a:fillRef idx="1">
+              <a:schemeClr val="accent1"/>
+            </a:fillRef>
+            <a:effectRef idx="0">
+              <a:schemeClr val="accent1"/>
+            </a:effectRef>
+            <a:fontRef idx="minor">
+              <a:schemeClr val="lt1"/>
+            </a:fontRef>
+          </p:style>
+          <p:txBody>
+            <a:bodyPr rtlCol="0" anchor="ctr"/>
+            <a:lstStyle/>
+            <a:p>
+              <a:pPr algn="ctr"/>
+              <a:endParaRPr lang="ko-KR" altLang="en-US"/>
+            </a:p>
+          </p:txBody>
+        </p:sp>
+        <p:sp>
+          <p:nvSpPr>
+            <p:cNvPr id="15" name="직사각형 14">
+              <a:extLst>
+                <a:ext uri="{FF2B5EF4-FFF2-40B4-BE49-F238E27FC236}">
+                  <a16:creationId xmlns:a16="http://schemas.microsoft.com/office/drawing/2014/main" id="{6A212AD7-BB36-4C42-B8F7-C8DA6FEEEB8E}"/>
+                </a:ext>
+              </a:extLst>
+            </p:cNvPr>
+            <p:cNvSpPr/>
+            <p:nvPr/>
+          </p:nvSpPr>
+          <p:spPr>
+            <a:xfrm>
+              <a:off x="3995500" y="4432209"/>
+              <a:ext cx="864367" cy="829068"/>
+            </a:xfrm>
+            <a:prstGeom prst="rect">
+              <a:avLst/>
+            </a:prstGeom>
+            <a:solidFill>
+              <a:schemeClr val="accent2"/>
+            </a:solidFill>
+          </p:spPr>
+          <p:style>
+            <a:lnRef idx="2">
+              <a:schemeClr val="accent1">
+                <a:shade val="50000"/>
+              </a:schemeClr>
+            </a:lnRef>
+            <a:fillRef idx="1">
+              <a:schemeClr val="accent1"/>
+            </a:fillRef>
+            <a:effectRef idx="0">
+              <a:schemeClr val="accent1"/>
+            </a:effectRef>
+            <a:fontRef idx="minor">
+              <a:schemeClr val="lt1"/>
+            </a:fontRef>
+          </p:style>
+          <p:txBody>
+            <a:bodyPr rtlCol="0" anchor="ctr"/>
+            <a:lstStyle/>
+            <a:p>
+              <a:pPr algn="ctr"/>
+              <a:r>
+                <a:rPr lang="ko-KR" altLang="en-US" sz="1400" dirty="0"/>
+                <a:t>분류</a:t>
+              </a:r>
+              <a:endParaRPr lang="en-US" altLang="ko-KR" sz="1400" dirty="0"/>
+            </a:p>
+            <a:p>
+              <a:pPr algn="ctr"/>
+              <a:r>
+                <a:rPr lang="ko-KR" altLang="en-US" sz="1400" dirty="0"/>
+                <a:t>불가품</a:t>
+              </a:r>
+            </a:p>
+          </p:txBody>
+        </p:sp>
+        <p:sp>
+          <p:nvSpPr>
+            <p:cNvPr id="21" name="직사각형 20">
+              <a:extLst>
+                <a:ext uri="{FF2B5EF4-FFF2-40B4-BE49-F238E27FC236}">
+                  <a16:creationId xmlns:a16="http://schemas.microsoft.com/office/drawing/2014/main" id="{EE0306F4-FF30-419F-8DC9-89211E6CD7AB}"/>
+                </a:ext>
+              </a:extLst>
+            </p:cNvPr>
+            <p:cNvSpPr/>
+            <p:nvPr/>
+          </p:nvSpPr>
+          <p:spPr>
+            <a:xfrm>
+              <a:off x="7332134" y="1596723"/>
+              <a:ext cx="864367" cy="829068"/>
+            </a:xfrm>
+            <a:prstGeom prst="rect">
+              <a:avLst/>
+            </a:prstGeom>
+            <a:solidFill>
+              <a:schemeClr val="accent2"/>
+            </a:solidFill>
+          </p:spPr>
+          <p:style>
+            <a:lnRef idx="2">
+              <a:schemeClr val="accent1">
+                <a:shade val="50000"/>
+              </a:schemeClr>
+            </a:lnRef>
+            <a:fillRef idx="1">
+              <a:schemeClr val="accent1"/>
+            </a:fillRef>
+            <a:effectRef idx="0">
+              <a:schemeClr val="accent1"/>
+            </a:effectRef>
+            <a:fontRef idx="minor">
+              <a:schemeClr val="lt1"/>
+            </a:fontRef>
+          </p:style>
+          <p:txBody>
+            <a:bodyPr rtlCol="0" anchor="ctr"/>
+            <a:lstStyle/>
+            <a:p>
+              <a:pPr algn="ctr"/>
+              <a:r>
+                <a:rPr lang="ko-KR" altLang="en-US" sz="1400" dirty="0"/>
+                <a:t>분류</a:t>
+              </a:r>
+              <a:endParaRPr lang="en-US" altLang="ko-KR" sz="1400" dirty="0"/>
+            </a:p>
+            <a:p>
+              <a:pPr algn="ctr"/>
+              <a:r>
+                <a:rPr lang="ko-KR" altLang="en-US" sz="1400" dirty="0"/>
+                <a:t>불가품</a:t>
+              </a:r>
+            </a:p>
+          </p:txBody>
+        </p:sp>
+        <p:sp>
+          <p:nvSpPr>
+            <p:cNvPr id="22" name="화살표: 아래쪽 21">
+              <a:extLst>
+                <a:ext uri="{FF2B5EF4-FFF2-40B4-BE49-F238E27FC236}">
+                  <a16:creationId xmlns:a16="http://schemas.microsoft.com/office/drawing/2014/main" id="{DA36CD22-8648-4ED0-9E45-68AEF4DD843A}"/>
+                </a:ext>
+              </a:extLst>
+            </p:cNvPr>
+            <p:cNvSpPr/>
+            <p:nvPr/>
+          </p:nvSpPr>
+          <p:spPr>
+            <a:xfrm>
+              <a:off x="6036730" y="6212946"/>
+              <a:ext cx="118535" cy="176252"/>
+            </a:xfrm>
+            <a:prstGeom prst="downArrow">
+              <a:avLst/>
+            </a:prstGeom>
+            <a:solidFill>
+              <a:schemeClr val="tx1"/>
+            </a:solidFill>
+          </p:spPr>
+          <p:style>
+            <a:lnRef idx="2">
+              <a:schemeClr val="accent1">
+                <a:shade val="50000"/>
+              </a:schemeClr>
+            </a:lnRef>
+            <a:fillRef idx="1">
+              <a:schemeClr val="accent1"/>
+            </a:fillRef>
+            <a:effectRef idx="0">
+              <a:schemeClr val="accent1"/>
+            </a:effectRef>
+            <a:fontRef idx="minor">
+              <a:schemeClr val="lt1"/>
+            </a:fontRef>
+          </p:style>
+          <p:txBody>
+            <a:bodyPr rtlCol="0" anchor="ctr"/>
+            <a:lstStyle/>
+            <a:p>
+              <a:pPr algn="ctr"/>
+              <a:endParaRPr lang="ko-KR" altLang="en-US"/>
+            </a:p>
+          </p:txBody>
+        </p:sp>
+        <p:sp>
+          <p:nvSpPr>
+            <p:cNvPr id="23" name="화살표: 아래쪽 22">
+              <a:extLst>
+                <a:ext uri="{FF2B5EF4-FFF2-40B4-BE49-F238E27FC236}">
+                  <a16:creationId xmlns:a16="http://schemas.microsoft.com/office/drawing/2014/main" id="{EBA16ACC-FD5E-4ED0-B818-A59696B544C9}"/>
+                </a:ext>
+              </a:extLst>
+            </p:cNvPr>
+            <p:cNvSpPr/>
+            <p:nvPr/>
+          </p:nvSpPr>
+          <p:spPr>
+            <a:xfrm rot="10800000">
+              <a:off x="6036730" y="488191"/>
+              <a:ext cx="118535" cy="176252"/>
+            </a:xfrm>
+            <a:prstGeom prst="downArrow">
+              <a:avLst/>
+            </a:prstGeom>
+            <a:solidFill>
+              <a:schemeClr val="tx1"/>
+            </a:solidFill>
+          </p:spPr>
+          <p:style>
+            <a:lnRef idx="2">
+              <a:schemeClr val="accent1">
+                <a:shade val="50000"/>
+              </a:schemeClr>
+            </a:lnRef>
+            <a:fillRef idx="1">
+              <a:schemeClr val="accent1"/>
+            </a:fillRef>
+            <a:effectRef idx="0">
+              <a:schemeClr val="accent1"/>
+            </a:effectRef>
+            <a:fontRef idx="minor">
+              <a:schemeClr val="lt1"/>
+            </a:fontRef>
+          </p:style>
+          <p:txBody>
+            <a:bodyPr rtlCol="0" anchor="ctr"/>
+            <a:lstStyle/>
+            <a:p>
+              <a:pPr algn="ctr"/>
+              <a:endParaRPr lang="ko-KR" altLang="en-US"/>
+            </a:p>
+          </p:txBody>
+        </p:sp>
+        <p:sp>
+          <p:nvSpPr>
+            <p:cNvPr id="24" name="직사각형 23">
+              <a:extLst>
+                <a:ext uri="{FF2B5EF4-FFF2-40B4-BE49-F238E27FC236}">
+                  <a16:creationId xmlns:a16="http://schemas.microsoft.com/office/drawing/2014/main" id="{9EF0F96B-512D-436E-A8D8-1E5EC870A9A3}"/>
+                </a:ext>
+              </a:extLst>
+            </p:cNvPr>
+            <p:cNvSpPr/>
+            <p:nvPr/>
+          </p:nvSpPr>
+          <p:spPr>
+            <a:xfrm>
+              <a:off x="3995499" y="5261277"/>
+              <a:ext cx="864367" cy="1171553"/>
+            </a:xfrm>
+            <a:prstGeom prst="rect">
+              <a:avLst/>
+            </a:prstGeom>
+            <a:solidFill>
+              <a:schemeClr val="accent6">
+                <a:lumMod val="40000"/>
+                <a:lumOff val="60000"/>
+              </a:schemeClr>
+            </a:solidFill>
+          </p:spPr>
+          <p:style>
+            <a:lnRef idx="2">
+              <a:schemeClr val="accent1">
+                <a:shade val="50000"/>
+              </a:schemeClr>
+            </a:lnRef>
+            <a:fillRef idx="1">
+              <a:schemeClr val="accent1"/>
+            </a:fillRef>
+            <a:effectRef idx="0">
+              <a:schemeClr val="accent1"/>
+            </a:effectRef>
+            <a:fontRef idx="minor">
+              <a:schemeClr val="lt1"/>
+            </a:fontRef>
+          </p:style>
+          <p:txBody>
+            <a:bodyPr rtlCol="0" anchor="ctr"/>
+            <a:lstStyle/>
+            <a:p>
+              <a:pPr algn="ctr"/>
+              <a:r>
+                <a:rPr lang="ko-KR" altLang="en-US" sz="1400" dirty="0"/>
+                <a:t>컨베</a:t>
+              </a:r>
+              <a:endParaRPr lang="en-US" altLang="ko-KR" sz="1400" dirty="0"/>
+            </a:p>
+            <a:p>
+              <a:pPr algn="ctr"/>
+              <a:r>
+                <a:rPr lang="ko-KR" altLang="en-US" sz="1400" dirty="0"/>
+                <a:t>이어</a:t>
+              </a:r>
+              <a:endParaRPr lang="en-US" altLang="ko-KR" sz="1400" dirty="0"/>
+            </a:p>
+            <a:p>
+              <a:pPr algn="ctr"/>
+              <a:r>
+                <a:rPr lang="ko-KR" altLang="en-US" sz="1400" dirty="0"/>
+                <a:t>벨트</a:t>
+              </a:r>
+              <a:endParaRPr lang="en-US" altLang="ko-KR" sz="1400" dirty="0"/>
+            </a:p>
+            <a:p>
+              <a:pPr algn="ctr"/>
+              <a:endParaRPr lang="ko-KR" altLang="en-US" dirty="0"/>
+            </a:p>
+          </p:txBody>
+        </p:sp>
+        <p:sp>
+          <p:nvSpPr>
+            <p:cNvPr id="25" name="화살표: 아래쪽 24">
+              <a:extLst>
+                <a:ext uri="{FF2B5EF4-FFF2-40B4-BE49-F238E27FC236}">
+                  <a16:creationId xmlns:a16="http://schemas.microsoft.com/office/drawing/2014/main" id="{58201DC9-43E2-4F4D-A28D-AAC797F6B916}"/>
+                </a:ext>
+              </a:extLst>
+            </p:cNvPr>
+            <p:cNvSpPr/>
+            <p:nvPr/>
+          </p:nvSpPr>
+          <p:spPr>
+            <a:xfrm>
+              <a:off x="4368414" y="6124820"/>
+              <a:ext cx="118535" cy="176252"/>
+            </a:xfrm>
+            <a:prstGeom prst="downArrow">
+              <a:avLst/>
+            </a:prstGeom>
+            <a:solidFill>
+              <a:schemeClr val="tx1"/>
+            </a:solidFill>
+          </p:spPr>
+          <p:style>
+            <a:lnRef idx="2">
+              <a:schemeClr val="accent1">
+                <a:shade val="50000"/>
+              </a:schemeClr>
+            </a:lnRef>
+            <a:fillRef idx="1">
+              <a:schemeClr val="accent1"/>
+            </a:fillRef>
+            <a:effectRef idx="0">
+              <a:schemeClr val="accent1"/>
+            </a:effectRef>
+            <a:fontRef idx="minor">
+              <a:schemeClr val="lt1"/>
+            </a:fontRef>
+          </p:style>
+          <p:txBody>
+            <a:bodyPr rtlCol="0" anchor="ctr"/>
+            <a:lstStyle/>
+            <a:p>
+              <a:pPr algn="ctr"/>
+              <a:endParaRPr lang="ko-KR" altLang="en-US"/>
+            </a:p>
+          </p:txBody>
+        </p:sp>
+        <p:sp>
+          <p:nvSpPr>
+            <p:cNvPr id="26" name="직사각형 25">
+              <a:extLst>
+                <a:ext uri="{FF2B5EF4-FFF2-40B4-BE49-F238E27FC236}">
+                  <a16:creationId xmlns:a16="http://schemas.microsoft.com/office/drawing/2014/main" id="{C94B24BE-A881-462A-B3F7-5C0A65C853AF}"/>
+                </a:ext>
+              </a:extLst>
+            </p:cNvPr>
+            <p:cNvSpPr/>
+            <p:nvPr/>
+          </p:nvSpPr>
+          <p:spPr>
+            <a:xfrm>
+              <a:off x="7332133" y="425170"/>
+              <a:ext cx="864367" cy="1171553"/>
+            </a:xfrm>
+            <a:prstGeom prst="rect">
+              <a:avLst/>
+            </a:prstGeom>
+            <a:solidFill>
+              <a:schemeClr val="accent6">
+                <a:lumMod val="40000"/>
+                <a:lumOff val="60000"/>
+              </a:schemeClr>
+            </a:solidFill>
+          </p:spPr>
+          <p:style>
+            <a:lnRef idx="2">
+              <a:schemeClr val="accent1">
+                <a:shade val="50000"/>
+              </a:schemeClr>
+            </a:lnRef>
+            <a:fillRef idx="1">
+              <a:schemeClr val="accent1"/>
+            </a:fillRef>
+            <a:effectRef idx="0">
+              <a:schemeClr val="accent1"/>
+            </a:effectRef>
+            <a:fontRef idx="minor">
+              <a:schemeClr val="lt1"/>
+            </a:fontRef>
+          </p:style>
+          <p:txBody>
+            <a:bodyPr rtlCol="0" anchor="ctr"/>
+            <a:lstStyle/>
+            <a:p>
+              <a:pPr algn="ctr"/>
+              <a:endParaRPr lang="en-US" altLang="ko-KR" sz="1400" dirty="0"/>
+            </a:p>
+            <a:p>
+              <a:pPr algn="ctr"/>
+              <a:r>
+                <a:rPr lang="ko-KR" altLang="en-US" sz="1400" dirty="0"/>
+                <a:t>컨베</a:t>
+              </a:r>
+              <a:endParaRPr lang="en-US" altLang="ko-KR" sz="1400" dirty="0"/>
+            </a:p>
+            <a:p>
+              <a:pPr algn="ctr"/>
+              <a:r>
+                <a:rPr lang="ko-KR" altLang="en-US" sz="1400" dirty="0"/>
+                <a:t>이어</a:t>
+              </a:r>
+              <a:endParaRPr lang="en-US" altLang="ko-KR" sz="1400" dirty="0"/>
+            </a:p>
+            <a:p>
+              <a:pPr algn="ctr"/>
+              <a:r>
+                <a:rPr lang="ko-KR" altLang="en-US" sz="1400" dirty="0"/>
+                <a:t>벨트</a:t>
+              </a:r>
+              <a:endParaRPr lang="en-US" altLang="ko-KR" sz="1400" dirty="0"/>
+            </a:p>
+          </p:txBody>
+        </p:sp>
+        <p:sp>
+          <p:nvSpPr>
+            <p:cNvPr id="27" name="화살표: 아래쪽 26">
+              <a:extLst>
+                <a:ext uri="{FF2B5EF4-FFF2-40B4-BE49-F238E27FC236}">
+                  <a16:creationId xmlns:a16="http://schemas.microsoft.com/office/drawing/2014/main" id="{B4B4B5DD-2BB6-4685-89A0-812E0EA8A450}"/>
+                </a:ext>
+              </a:extLst>
+            </p:cNvPr>
+            <p:cNvSpPr/>
+            <p:nvPr/>
+          </p:nvSpPr>
+          <p:spPr>
+            <a:xfrm rot="10800000">
+              <a:off x="7688114" y="535708"/>
+              <a:ext cx="118535" cy="176252"/>
+            </a:xfrm>
+            <a:prstGeom prst="downArrow">
+              <a:avLst/>
+            </a:prstGeom>
+            <a:solidFill>
+              <a:schemeClr val="tx1"/>
+            </a:solidFill>
+          </p:spPr>
+          <p:style>
+            <a:lnRef idx="2">
+              <a:schemeClr val="accent1">
+                <a:shade val="50000"/>
+              </a:schemeClr>
+            </a:lnRef>
+            <a:fillRef idx="1">
+              <a:schemeClr val="accent1"/>
+            </a:fillRef>
+            <a:effectRef idx="0">
+              <a:schemeClr val="accent1"/>
+            </a:effectRef>
+            <a:fontRef idx="minor">
+              <a:schemeClr val="lt1"/>
+            </a:fontRef>
+          </p:style>
+          <p:txBody>
+            <a:bodyPr rtlCol="0" anchor="ctr"/>
+            <a:lstStyle/>
+            <a:p>
+              <a:pPr algn="ctr"/>
+              <a:endParaRPr lang="ko-KR" altLang="en-US"/>
+            </a:p>
+          </p:txBody>
+        </p:sp>
       </p:grpSp>
-      <p:sp>
-        <p:nvSpPr>
-          <p:cNvPr id="26" name="TextBox 25">
-            <a:extLst>
-              <a:ext uri="{FF2B5EF4-FFF2-40B4-BE49-F238E27FC236}">
-                <a16:creationId xmlns:a16="http://schemas.microsoft.com/office/drawing/2014/main" id="{44517D35-A087-411C-BA94-97B99C6409BE}"/>
-              </a:ext>
-            </a:extLst>
-          </p:cNvPr>
-          <p:cNvSpPr txBox="1"/>
-          <p:nvPr/>
-        </p:nvSpPr>
-        <p:spPr>
-          <a:xfrm>
-            <a:off x="5339222" y="593510"/>
-            <a:ext cx="1513556" cy="369332"/>
-          </a:xfrm>
-          <a:prstGeom prst="rect">
-            <a:avLst/>
-          </a:prstGeom>
-          <a:noFill/>
-        </p:spPr>
-        <p:txBody>
-          <a:bodyPr wrap="none" rtlCol="0">
-            <a:spAutoFit/>
-          </a:bodyPr>
-          <a:lstStyle/>
-          <a:p>
-            <a:r>
-              <a:rPr lang="en-US" altLang="ko-KR" dirty="0"/>
-              <a:t>&lt;</a:t>
-            </a:r>
-            <a:r>
-              <a:rPr lang="ko-KR" altLang="en-US" dirty="0"/>
-              <a:t>작업 공간</a:t>
-            </a:r>
-            <a:r>
-              <a:rPr lang="en-US" altLang="ko-KR" dirty="0"/>
-              <a:t>&gt;</a:t>
-            </a:r>
-            <a:endParaRPr lang="ko-KR" altLang="en-US" dirty="0"/>
-          </a:p>
-        </p:txBody>
-      </p:sp>
-    </p:spTree>
-    <p:extLst>
-      <p:ext uri="{BB962C8B-B14F-4D97-AF65-F5344CB8AC3E}">
-        <p14:creationId xmlns:p14="http://schemas.microsoft.com/office/powerpoint/2010/main" val="2386937432"/>
-      </p:ext>
-    </p:extLst>
-  </p:cSld>
-  <p:clrMapOvr>
-    <a:masterClrMapping/>
-  </p:clrMapOvr>
-</p:sld>
-</file>
-
-<file path=ppt/slides/slide2.xml><?xml version="1.0" encoding="utf-8"?>
-<p:sld xmlns:a="http://schemas.openxmlformats.org/drawingml/2006/main" xmlns:r="http://schemas.openxmlformats.org/officeDocument/2006/relationships" xmlns:p="http://schemas.openxmlformats.org/presentationml/2006/main">
-  <p:cSld>
-    <p:spTree>
-      <p:nvGrpSpPr>
-        <p:cNvPr id="1" name=""/>
-        <p:cNvGrpSpPr/>
-        <p:nvPr/>
-      </p:nvGrpSpPr>
-      <p:grpSpPr>
-        <a:xfrm>
-          <a:off x="0" y="0"/>
-          <a:ext cx="0" cy="0"/>
-          <a:chOff x="0" y="0"/>
-          <a:chExt cx="0" cy="0"/>
-        </a:xfrm>
-      </p:grpSpPr>
     </p:spTree>
     <p:extLst>
       <p:ext uri="{BB962C8B-B14F-4D97-AF65-F5344CB8AC3E}">

</xml_diff>

<commit_message>
Modify robot work space image in README.md file.
</commit_message>
<xml_diff>
--- a/documents/scenario_and_prd/work_space.pptx
+++ b/documents/scenario_and_prd/work_space.pptx
@@ -38,7 +38,7 @@
             <a:spLocks noGrp="1"/>
           </p:cNvSpPr>
           <p:nvPr>
-            <p:ph type="ftr" idx="2"/>
+            <p:ph type="ftr" idx="1"/>
           </p:nvPr>
         </p:nvSpPr>
         <p:spPr/>
@@ -58,14 +58,14 @@
             <a:spLocks noGrp="1"/>
           </p:cNvSpPr>
           <p:nvPr>
-            <p:ph type="sldNum" idx="3"/>
+            <p:ph type="sldNum" idx="2"/>
           </p:nvPr>
         </p:nvSpPr>
         <p:spPr/>
         <p:txBody>
           <a:bodyPr/>
           <a:p>
-            <a:fld id="{BF4C9361-CD7E-46FA-99E7-43D4AAC2E0DB}" type="slidenum">
+            <a:fld id="{A7BF45EF-4CF8-462C-9EFB-73AC3BE234D9}" type="slidenum">
               <a:t>&lt;#&gt;</a:t>
             </a:fld>
           </a:p>
@@ -78,7 +78,7 @@
             <a:spLocks noGrp="1"/>
           </p:cNvSpPr>
           <p:nvPr>
-            <p:ph type="dt" idx="1"/>
+            <p:ph type="dt" idx="3"/>
           </p:nvPr>
         </p:nvSpPr>
         <p:spPr/>
@@ -127,7 +127,7 @@
         <p:spPr>
           <a:xfrm>
             <a:off x="1523880" y="1122480"/>
-            <a:ext cx="9143640" cy="2387160"/>
+            <a:ext cx="9143280" cy="2386800"/>
           </a:xfrm>
           <a:prstGeom prst="rect">
             <a:avLst/>
@@ -142,11 +142,11 @@
             <a:noAutofit/>
           </a:bodyPr>
           <a:p>
-            <a:endParaRPr b="0" lang="en-US" sz="1800" spc="-1" strike="noStrike">
-              <a:solidFill>
-                <a:srgbClr val="000000"/>
-              </a:solidFill>
-              <a:latin typeface="맑은 고딕"/>
+            <a:pPr algn="ctr">
+              <a:buNone/>
+            </a:pPr>
+            <a:endParaRPr b="0" lang="en-US" sz="4400" spc="-1" strike="noStrike">
+              <a:latin typeface="Arial"/>
             </a:endParaRPr>
           </a:p>
         </p:txBody>
@@ -179,20 +179,8 @@
             <a:normAutofit/>
           </a:bodyPr>
           <a:p>
-            <a:pPr>
-              <a:lnSpc>
-                <a:spcPct val="90000"/>
-              </a:lnSpc>
-              <a:spcBef>
-                <a:spcPts val="1417"/>
-              </a:spcBef>
-              <a:buNone/>
-            </a:pPr>
-            <a:endParaRPr b="0" lang="en-US" sz="2800" spc="-1" strike="noStrike">
-              <a:solidFill>
-                <a:srgbClr val="000000"/>
-              </a:solidFill>
-              <a:latin typeface="맑은 고딕"/>
+            <a:endParaRPr b="0" lang="en-US" sz="3200" spc="-1" strike="noStrike">
+              <a:latin typeface="Arial"/>
             </a:endParaRPr>
           </a:p>
         </p:txBody>
@@ -225,20 +213,8 @@
             <a:normAutofit/>
           </a:bodyPr>
           <a:p>
-            <a:pPr>
-              <a:lnSpc>
-                <a:spcPct val="90000"/>
-              </a:lnSpc>
-              <a:spcBef>
-                <a:spcPts val="1417"/>
-              </a:spcBef>
-              <a:buNone/>
-            </a:pPr>
-            <a:endParaRPr b="0" lang="en-US" sz="2800" spc="-1" strike="noStrike">
-              <a:solidFill>
-                <a:srgbClr val="000000"/>
-              </a:solidFill>
-              <a:latin typeface="맑은 고딕"/>
+            <a:endParaRPr b="0" lang="en-US" sz="3200" spc="-1" strike="noStrike">
+              <a:latin typeface="Arial"/>
             </a:endParaRPr>
           </a:p>
         </p:txBody>
@@ -250,7 +226,7 @@
             <a:spLocks noGrp="1"/>
           </p:cNvSpPr>
           <p:nvPr>
-            <p:ph type="ftr" idx="2"/>
+            <p:ph type="ftr" idx="1"/>
           </p:nvPr>
         </p:nvSpPr>
         <p:spPr/>
@@ -270,14 +246,14 @@
             <a:spLocks noGrp="1"/>
           </p:cNvSpPr>
           <p:nvPr>
-            <p:ph type="sldNum" idx="3"/>
+            <p:ph type="sldNum" idx="2"/>
           </p:nvPr>
         </p:nvSpPr>
         <p:spPr/>
         <p:txBody>
           <a:bodyPr/>
           <a:p>
-            <a:fld id="{C515D40E-7A27-4A24-A2B5-5A41C8021AB4}" type="slidenum">
+            <a:fld id="{E5B0462A-EEB4-4406-A152-671124152C3C}" type="slidenum">
               <a:t>&lt;#&gt;</a:t>
             </a:fld>
           </a:p>
@@ -290,7 +266,7 @@
             <a:spLocks noGrp="1"/>
           </p:cNvSpPr>
           <p:nvPr>
-            <p:ph type="dt" idx="1"/>
+            <p:ph type="dt" idx="3"/>
           </p:nvPr>
         </p:nvSpPr>
         <p:spPr/>
@@ -339,7 +315,7 @@
         <p:spPr>
           <a:xfrm>
             <a:off x="1523880" y="1122480"/>
-            <a:ext cx="9143640" cy="2387160"/>
+            <a:ext cx="9143280" cy="2386800"/>
           </a:xfrm>
           <a:prstGeom prst="rect">
             <a:avLst/>
@@ -354,11 +330,11 @@
             <a:noAutofit/>
           </a:bodyPr>
           <a:p>
-            <a:endParaRPr b="0" lang="en-US" sz="1800" spc="-1" strike="noStrike">
-              <a:solidFill>
-                <a:srgbClr val="000000"/>
-              </a:solidFill>
-              <a:latin typeface="맑은 고딕"/>
+            <a:pPr algn="ctr">
+              <a:buNone/>
+            </a:pPr>
+            <a:endParaRPr b="0" lang="en-US" sz="4400" spc="-1" strike="noStrike">
+              <a:latin typeface="Arial"/>
             </a:endParaRPr>
           </a:p>
         </p:txBody>
@@ -391,20 +367,8 @@
             <a:normAutofit/>
           </a:bodyPr>
           <a:p>
-            <a:pPr>
-              <a:lnSpc>
-                <a:spcPct val="90000"/>
-              </a:lnSpc>
-              <a:spcBef>
-                <a:spcPts val="1417"/>
-              </a:spcBef>
-              <a:buNone/>
-            </a:pPr>
-            <a:endParaRPr b="0" lang="en-US" sz="2800" spc="-1" strike="noStrike">
-              <a:solidFill>
-                <a:srgbClr val="000000"/>
-              </a:solidFill>
-              <a:latin typeface="맑은 고딕"/>
+            <a:endParaRPr b="0" lang="en-US" sz="3200" spc="-1" strike="noStrike">
+              <a:latin typeface="Arial"/>
             </a:endParaRPr>
           </a:p>
         </p:txBody>
@@ -437,20 +401,8 @@
             <a:normAutofit/>
           </a:bodyPr>
           <a:p>
-            <a:pPr>
-              <a:lnSpc>
-                <a:spcPct val="90000"/>
-              </a:lnSpc>
-              <a:spcBef>
-                <a:spcPts val="1417"/>
-              </a:spcBef>
-              <a:buNone/>
-            </a:pPr>
-            <a:endParaRPr b="0" lang="en-US" sz="2800" spc="-1" strike="noStrike">
-              <a:solidFill>
-                <a:srgbClr val="000000"/>
-              </a:solidFill>
-              <a:latin typeface="맑은 고딕"/>
+            <a:endParaRPr b="0" lang="en-US" sz="3200" spc="-1" strike="noStrike">
+              <a:latin typeface="Arial"/>
             </a:endParaRPr>
           </a:p>
         </p:txBody>
@@ -483,20 +435,8 @@
             <a:normAutofit/>
           </a:bodyPr>
           <a:p>
-            <a:pPr>
-              <a:lnSpc>
-                <a:spcPct val="90000"/>
-              </a:lnSpc>
-              <a:spcBef>
-                <a:spcPts val="1417"/>
-              </a:spcBef>
-              <a:buNone/>
-            </a:pPr>
-            <a:endParaRPr b="0" lang="en-US" sz="2800" spc="-1" strike="noStrike">
-              <a:solidFill>
-                <a:srgbClr val="000000"/>
-              </a:solidFill>
-              <a:latin typeface="맑은 고딕"/>
+            <a:endParaRPr b="0" lang="en-US" sz="3200" spc="-1" strike="noStrike">
+              <a:latin typeface="Arial"/>
             </a:endParaRPr>
           </a:p>
         </p:txBody>
@@ -529,20 +469,8 @@
             <a:normAutofit/>
           </a:bodyPr>
           <a:p>
-            <a:pPr>
-              <a:lnSpc>
-                <a:spcPct val="90000"/>
-              </a:lnSpc>
-              <a:spcBef>
-                <a:spcPts val="1417"/>
-              </a:spcBef>
-              <a:buNone/>
-            </a:pPr>
-            <a:endParaRPr b="0" lang="en-US" sz="2800" spc="-1" strike="noStrike">
-              <a:solidFill>
-                <a:srgbClr val="000000"/>
-              </a:solidFill>
-              <a:latin typeface="맑은 고딕"/>
+            <a:endParaRPr b="0" lang="en-US" sz="3200" spc="-1" strike="noStrike">
+              <a:latin typeface="Arial"/>
             </a:endParaRPr>
           </a:p>
         </p:txBody>
@@ -554,7 +482,7 @@
             <a:spLocks noGrp="1"/>
           </p:cNvSpPr>
           <p:nvPr>
-            <p:ph type="ftr" idx="2"/>
+            <p:ph type="ftr" idx="1"/>
           </p:nvPr>
         </p:nvSpPr>
         <p:spPr/>
@@ -574,14 +502,14 @@
             <a:spLocks noGrp="1"/>
           </p:cNvSpPr>
           <p:nvPr>
-            <p:ph type="sldNum" idx="3"/>
+            <p:ph type="sldNum" idx="2"/>
           </p:nvPr>
         </p:nvSpPr>
         <p:spPr/>
         <p:txBody>
           <a:bodyPr/>
           <a:p>
-            <a:fld id="{B889FC73-B0EA-4888-9AD6-A445E58E8E4F}" type="slidenum">
+            <a:fld id="{D6FBC5C4-E33D-4E9B-AE07-689134210235}" type="slidenum">
               <a:t>&lt;#&gt;</a:t>
             </a:fld>
           </a:p>
@@ -594,7 +522,7 @@
             <a:spLocks noGrp="1"/>
           </p:cNvSpPr>
           <p:nvPr>
-            <p:ph type="dt" idx="1"/>
+            <p:ph type="dt" idx="3"/>
           </p:nvPr>
         </p:nvSpPr>
         <p:spPr/>
@@ -643,7 +571,7 @@
         <p:spPr>
           <a:xfrm>
             <a:off x="1523880" y="1122480"/>
-            <a:ext cx="9143640" cy="2387160"/>
+            <a:ext cx="9143280" cy="2386800"/>
           </a:xfrm>
           <a:prstGeom prst="rect">
             <a:avLst/>
@@ -658,11 +586,11 @@
             <a:noAutofit/>
           </a:bodyPr>
           <a:p>
-            <a:endParaRPr b="0" lang="en-US" sz="1800" spc="-1" strike="noStrike">
-              <a:solidFill>
-                <a:srgbClr val="000000"/>
-              </a:solidFill>
-              <a:latin typeface="맑은 고딕"/>
+            <a:pPr algn="ctr">
+              <a:buNone/>
+            </a:pPr>
+            <a:endParaRPr b="0" lang="en-US" sz="4400" spc="-1" strike="noStrike">
+              <a:latin typeface="Arial"/>
             </a:endParaRPr>
           </a:p>
         </p:txBody>
@@ -695,20 +623,8 @@
             <a:normAutofit/>
           </a:bodyPr>
           <a:p>
-            <a:pPr>
-              <a:lnSpc>
-                <a:spcPct val="90000"/>
-              </a:lnSpc>
-              <a:spcBef>
-                <a:spcPts val="1417"/>
-              </a:spcBef>
-              <a:buNone/>
-            </a:pPr>
-            <a:endParaRPr b="0" lang="en-US" sz="2800" spc="-1" strike="noStrike">
-              <a:solidFill>
-                <a:srgbClr val="000000"/>
-              </a:solidFill>
-              <a:latin typeface="맑은 고딕"/>
+            <a:endParaRPr b="0" lang="en-US" sz="3200" spc="-1" strike="noStrike">
+              <a:latin typeface="Arial"/>
             </a:endParaRPr>
           </a:p>
         </p:txBody>
@@ -741,20 +657,8 @@
             <a:normAutofit/>
           </a:bodyPr>
           <a:p>
-            <a:pPr>
-              <a:lnSpc>
-                <a:spcPct val="90000"/>
-              </a:lnSpc>
-              <a:spcBef>
-                <a:spcPts val="1417"/>
-              </a:spcBef>
-              <a:buNone/>
-            </a:pPr>
-            <a:endParaRPr b="0" lang="en-US" sz="2800" spc="-1" strike="noStrike">
-              <a:solidFill>
-                <a:srgbClr val="000000"/>
-              </a:solidFill>
-              <a:latin typeface="맑은 고딕"/>
+            <a:endParaRPr b="0" lang="en-US" sz="3200" spc="-1" strike="noStrike">
+              <a:latin typeface="Arial"/>
             </a:endParaRPr>
           </a:p>
         </p:txBody>
@@ -787,20 +691,8 @@
             <a:normAutofit/>
           </a:bodyPr>
           <a:p>
-            <a:pPr>
-              <a:lnSpc>
-                <a:spcPct val="90000"/>
-              </a:lnSpc>
-              <a:spcBef>
-                <a:spcPts val="1417"/>
-              </a:spcBef>
-              <a:buNone/>
-            </a:pPr>
-            <a:endParaRPr b="0" lang="en-US" sz="2800" spc="-1" strike="noStrike">
-              <a:solidFill>
-                <a:srgbClr val="000000"/>
-              </a:solidFill>
-              <a:latin typeface="맑은 고딕"/>
+            <a:endParaRPr b="0" lang="en-US" sz="3200" spc="-1" strike="noStrike">
+              <a:latin typeface="Arial"/>
             </a:endParaRPr>
           </a:p>
         </p:txBody>
@@ -833,20 +725,8 @@
             <a:normAutofit/>
           </a:bodyPr>
           <a:p>
-            <a:pPr>
-              <a:lnSpc>
-                <a:spcPct val="90000"/>
-              </a:lnSpc>
-              <a:spcBef>
-                <a:spcPts val="1417"/>
-              </a:spcBef>
-              <a:buNone/>
-            </a:pPr>
-            <a:endParaRPr b="0" lang="en-US" sz="2800" spc="-1" strike="noStrike">
-              <a:solidFill>
-                <a:srgbClr val="000000"/>
-              </a:solidFill>
-              <a:latin typeface="맑은 고딕"/>
+            <a:endParaRPr b="0" lang="en-US" sz="3200" spc="-1" strike="noStrike">
+              <a:latin typeface="Arial"/>
             </a:endParaRPr>
           </a:p>
         </p:txBody>
@@ -879,20 +759,8 @@
             <a:normAutofit/>
           </a:bodyPr>
           <a:p>
-            <a:pPr>
-              <a:lnSpc>
-                <a:spcPct val="90000"/>
-              </a:lnSpc>
-              <a:spcBef>
-                <a:spcPts val="1417"/>
-              </a:spcBef>
-              <a:buNone/>
-            </a:pPr>
-            <a:endParaRPr b="0" lang="en-US" sz="2800" spc="-1" strike="noStrike">
-              <a:solidFill>
-                <a:srgbClr val="000000"/>
-              </a:solidFill>
-              <a:latin typeface="맑은 고딕"/>
+            <a:endParaRPr b="0" lang="en-US" sz="3200" spc="-1" strike="noStrike">
+              <a:latin typeface="Arial"/>
             </a:endParaRPr>
           </a:p>
         </p:txBody>
@@ -925,20 +793,8 @@
             <a:normAutofit/>
           </a:bodyPr>
           <a:p>
-            <a:pPr>
-              <a:lnSpc>
-                <a:spcPct val="90000"/>
-              </a:lnSpc>
-              <a:spcBef>
-                <a:spcPts val="1417"/>
-              </a:spcBef>
-              <a:buNone/>
-            </a:pPr>
-            <a:endParaRPr b="0" lang="en-US" sz="2800" spc="-1" strike="noStrike">
-              <a:solidFill>
-                <a:srgbClr val="000000"/>
-              </a:solidFill>
-              <a:latin typeface="맑은 고딕"/>
+            <a:endParaRPr b="0" lang="en-US" sz="3200" spc="-1" strike="noStrike">
+              <a:latin typeface="Arial"/>
             </a:endParaRPr>
           </a:p>
         </p:txBody>
@@ -950,7 +806,7 @@
             <a:spLocks noGrp="1"/>
           </p:cNvSpPr>
           <p:nvPr>
-            <p:ph type="ftr" idx="2"/>
+            <p:ph type="ftr" idx="1"/>
           </p:nvPr>
         </p:nvSpPr>
         <p:spPr/>
@@ -970,14 +826,14 @@
             <a:spLocks noGrp="1"/>
           </p:cNvSpPr>
           <p:nvPr>
-            <p:ph type="sldNum" idx="3"/>
+            <p:ph type="sldNum" idx="2"/>
           </p:nvPr>
         </p:nvSpPr>
         <p:spPr/>
         <p:txBody>
           <a:bodyPr/>
           <a:p>
-            <a:fld id="{E35D88C5-B0C2-4C33-B9AB-EE4D2747C33B}" type="slidenum">
+            <a:fld id="{575D251C-CD1E-4BC7-A7B1-C22CDD528280}" type="slidenum">
               <a:t>&lt;#&gt;</a:t>
             </a:fld>
           </a:p>
@@ -990,7 +846,7 @@
             <a:spLocks noGrp="1"/>
           </p:cNvSpPr>
           <p:nvPr>
-            <p:ph type="dt" idx="1"/>
+            <p:ph type="dt" idx="3"/>
           </p:nvPr>
         </p:nvSpPr>
         <p:spPr/>
@@ -1039,7 +895,7 @@
         <p:spPr>
           <a:xfrm>
             <a:off x="1523880" y="1122480"/>
-            <a:ext cx="9143640" cy="2387160"/>
+            <a:ext cx="9143280" cy="2386800"/>
           </a:xfrm>
           <a:prstGeom prst="rect">
             <a:avLst/>
@@ -1054,11 +910,11 @@
             <a:noAutofit/>
           </a:bodyPr>
           <a:p>
-            <a:endParaRPr b="0" lang="en-US" sz="1800" spc="-1" strike="noStrike">
-              <a:solidFill>
-                <a:srgbClr val="000000"/>
-              </a:solidFill>
-              <a:latin typeface="맑은 고딕"/>
+            <a:pPr algn="ctr">
+              <a:buNone/>
+            </a:pPr>
+            <a:endParaRPr b="0" lang="en-US" sz="4400" spc="-1" strike="noStrike">
+              <a:latin typeface="Arial"/>
             </a:endParaRPr>
           </a:p>
         </p:txBody>
@@ -1107,7 +963,7 @@
             <a:spLocks noGrp="1"/>
           </p:cNvSpPr>
           <p:nvPr>
-            <p:ph type="ftr" idx="2"/>
+            <p:ph type="ftr" idx="1"/>
           </p:nvPr>
         </p:nvSpPr>
         <p:spPr/>
@@ -1127,14 +983,14 @@
             <a:spLocks noGrp="1"/>
           </p:cNvSpPr>
           <p:nvPr>
-            <p:ph type="sldNum" idx="3"/>
+            <p:ph type="sldNum" idx="2"/>
           </p:nvPr>
         </p:nvSpPr>
         <p:spPr/>
         <p:txBody>
           <a:bodyPr/>
           <a:p>
-            <a:fld id="{61CED422-1AEC-4E5D-ACC0-01EDF09490C9}" type="slidenum">
+            <a:fld id="{CA2767D9-E84C-48EA-B2FC-2A661064C614}" type="slidenum">
               <a:t>&lt;#&gt;</a:t>
             </a:fld>
           </a:p>
@@ -1147,7 +1003,7 @@
             <a:spLocks noGrp="1"/>
           </p:cNvSpPr>
           <p:nvPr>
-            <p:ph type="dt" idx="1"/>
+            <p:ph type="dt" idx="3"/>
           </p:nvPr>
         </p:nvSpPr>
         <p:spPr/>
@@ -1196,7 +1052,7 @@
         <p:spPr>
           <a:xfrm>
             <a:off x="1523880" y="1122480"/>
-            <a:ext cx="9143640" cy="2387160"/>
+            <a:ext cx="9143280" cy="2386800"/>
           </a:xfrm>
           <a:prstGeom prst="rect">
             <a:avLst/>
@@ -1211,11 +1067,11 @@
             <a:noAutofit/>
           </a:bodyPr>
           <a:p>
-            <a:endParaRPr b="0" lang="en-US" sz="1800" spc="-1" strike="noStrike">
-              <a:solidFill>
-                <a:srgbClr val="000000"/>
-              </a:solidFill>
-              <a:latin typeface="맑은 고딕"/>
+            <a:pPr algn="ctr">
+              <a:buNone/>
+            </a:pPr>
+            <a:endParaRPr b="0" lang="en-US" sz="4400" spc="-1" strike="noStrike">
+              <a:latin typeface="Arial"/>
             </a:endParaRPr>
           </a:p>
         </p:txBody>
@@ -1248,20 +1104,8 @@
             <a:normAutofit/>
           </a:bodyPr>
           <a:p>
-            <a:pPr>
-              <a:lnSpc>
-                <a:spcPct val="90000"/>
-              </a:lnSpc>
-              <a:spcBef>
-                <a:spcPts val="1417"/>
-              </a:spcBef>
-              <a:buNone/>
-            </a:pPr>
-            <a:endParaRPr b="0" lang="en-US" sz="2800" spc="-1" strike="noStrike">
-              <a:solidFill>
-                <a:srgbClr val="000000"/>
-              </a:solidFill>
-              <a:latin typeface="맑은 고딕"/>
+            <a:endParaRPr b="0" lang="en-US" sz="3200" spc="-1" strike="noStrike">
+              <a:latin typeface="Arial"/>
             </a:endParaRPr>
           </a:p>
         </p:txBody>
@@ -1273,7 +1117,7 @@
             <a:spLocks noGrp="1"/>
           </p:cNvSpPr>
           <p:nvPr>
-            <p:ph type="ftr" idx="2"/>
+            <p:ph type="ftr" idx="1"/>
           </p:nvPr>
         </p:nvSpPr>
         <p:spPr/>
@@ -1293,14 +1137,14 @@
             <a:spLocks noGrp="1"/>
           </p:cNvSpPr>
           <p:nvPr>
-            <p:ph type="sldNum" idx="3"/>
+            <p:ph type="sldNum" idx="2"/>
           </p:nvPr>
         </p:nvSpPr>
         <p:spPr/>
         <p:txBody>
           <a:bodyPr/>
           <a:p>
-            <a:fld id="{2467D094-72A4-47FB-9649-510319C06239}" type="slidenum">
+            <a:fld id="{C8A78E1E-C5FD-4143-8A3E-79302CF06A5B}" type="slidenum">
               <a:t>&lt;#&gt;</a:t>
             </a:fld>
           </a:p>
@@ -1313,7 +1157,7 @@
             <a:spLocks noGrp="1"/>
           </p:cNvSpPr>
           <p:nvPr>
-            <p:ph type="dt" idx="1"/>
+            <p:ph type="dt" idx="3"/>
           </p:nvPr>
         </p:nvSpPr>
         <p:spPr/>
@@ -1362,7 +1206,7 @@
         <p:spPr>
           <a:xfrm>
             <a:off x="1523880" y="1122480"/>
-            <a:ext cx="9143640" cy="2387160"/>
+            <a:ext cx="9143280" cy="2386800"/>
           </a:xfrm>
           <a:prstGeom prst="rect">
             <a:avLst/>
@@ -1377,11 +1221,11 @@
             <a:noAutofit/>
           </a:bodyPr>
           <a:p>
-            <a:endParaRPr b="0" lang="en-US" sz="1800" spc="-1" strike="noStrike">
-              <a:solidFill>
-                <a:srgbClr val="000000"/>
-              </a:solidFill>
-              <a:latin typeface="맑은 고딕"/>
+            <a:pPr algn="ctr">
+              <a:buNone/>
+            </a:pPr>
+            <a:endParaRPr b="0" lang="en-US" sz="4400" spc="-1" strike="noStrike">
+              <a:latin typeface="Arial"/>
             </a:endParaRPr>
           </a:p>
         </p:txBody>
@@ -1414,20 +1258,8 @@
             <a:normAutofit/>
           </a:bodyPr>
           <a:p>
-            <a:pPr>
-              <a:lnSpc>
-                <a:spcPct val="90000"/>
-              </a:lnSpc>
-              <a:spcBef>
-                <a:spcPts val="1417"/>
-              </a:spcBef>
-              <a:buNone/>
-            </a:pPr>
-            <a:endParaRPr b="0" lang="en-US" sz="2800" spc="-1" strike="noStrike">
-              <a:solidFill>
-                <a:srgbClr val="000000"/>
-              </a:solidFill>
-              <a:latin typeface="맑은 고딕"/>
+            <a:endParaRPr b="0" lang="en-US" sz="3200" spc="-1" strike="noStrike">
+              <a:latin typeface="Arial"/>
             </a:endParaRPr>
           </a:p>
         </p:txBody>
@@ -1460,20 +1292,8 @@
             <a:normAutofit/>
           </a:bodyPr>
           <a:p>
-            <a:pPr>
-              <a:lnSpc>
-                <a:spcPct val="90000"/>
-              </a:lnSpc>
-              <a:spcBef>
-                <a:spcPts val="1417"/>
-              </a:spcBef>
-              <a:buNone/>
-            </a:pPr>
-            <a:endParaRPr b="0" lang="en-US" sz="2800" spc="-1" strike="noStrike">
-              <a:solidFill>
-                <a:srgbClr val="000000"/>
-              </a:solidFill>
-              <a:latin typeface="맑은 고딕"/>
+            <a:endParaRPr b="0" lang="en-US" sz="3200" spc="-1" strike="noStrike">
+              <a:latin typeface="Arial"/>
             </a:endParaRPr>
           </a:p>
         </p:txBody>
@@ -1485,7 +1305,7 @@
             <a:spLocks noGrp="1"/>
           </p:cNvSpPr>
           <p:nvPr>
-            <p:ph type="ftr" idx="2"/>
+            <p:ph type="ftr" idx="1"/>
           </p:nvPr>
         </p:nvSpPr>
         <p:spPr/>
@@ -1505,14 +1325,14 @@
             <a:spLocks noGrp="1"/>
           </p:cNvSpPr>
           <p:nvPr>
-            <p:ph type="sldNum" idx="3"/>
+            <p:ph type="sldNum" idx="2"/>
           </p:nvPr>
         </p:nvSpPr>
         <p:spPr/>
         <p:txBody>
           <a:bodyPr/>
           <a:p>
-            <a:fld id="{6771C900-8029-4D4B-874E-8C36E53BAC3A}" type="slidenum">
+            <a:fld id="{F6A6C0F5-EAD0-40E0-A2F6-677A065D9971}" type="slidenum">
               <a:t>&lt;#&gt;</a:t>
             </a:fld>
           </a:p>
@@ -1525,7 +1345,7 @@
             <a:spLocks noGrp="1"/>
           </p:cNvSpPr>
           <p:nvPr>
-            <p:ph type="dt" idx="1"/>
+            <p:ph type="dt" idx="3"/>
           </p:nvPr>
         </p:nvSpPr>
         <p:spPr/>
@@ -1574,7 +1394,7 @@
         <p:spPr>
           <a:xfrm>
             <a:off x="1523880" y="1122480"/>
-            <a:ext cx="9143640" cy="2387160"/>
+            <a:ext cx="9143280" cy="2386800"/>
           </a:xfrm>
           <a:prstGeom prst="rect">
             <a:avLst/>
@@ -1589,11 +1409,11 @@
             <a:noAutofit/>
           </a:bodyPr>
           <a:p>
-            <a:endParaRPr b="0" lang="en-US" sz="1800" spc="-1" strike="noStrike">
-              <a:solidFill>
-                <a:srgbClr val="000000"/>
-              </a:solidFill>
-              <a:latin typeface="맑은 고딕"/>
+            <a:pPr algn="ctr">
+              <a:buNone/>
+            </a:pPr>
+            <a:endParaRPr b="0" lang="en-US" sz="4400" spc="-1" strike="noStrike">
+              <a:latin typeface="Arial"/>
             </a:endParaRPr>
           </a:p>
         </p:txBody>
@@ -1605,7 +1425,7 @@
             <a:spLocks noGrp="1"/>
           </p:cNvSpPr>
           <p:nvPr>
-            <p:ph type="ftr" idx="2"/>
+            <p:ph type="ftr" idx="1"/>
           </p:nvPr>
         </p:nvSpPr>
         <p:spPr/>
@@ -1625,14 +1445,14 @@
             <a:spLocks noGrp="1"/>
           </p:cNvSpPr>
           <p:nvPr>
-            <p:ph type="sldNum" idx="3"/>
+            <p:ph type="sldNum" idx="2"/>
           </p:nvPr>
         </p:nvSpPr>
         <p:spPr/>
         <p:txBody>
           <a:bodyPr/>
           <a:p>
-            <a:fld id="{5E59A493-2D04-48A0-AC10-DB6B52069CAA}" type="slidenum">
+            <a:fld id="{39EDF4D5-0921-4277-8A43-14B6594C835C}" type="slidenum">
               <a:t>&lt;#&gt;</a:t>
             </a:fld>
           </a:p>
@@ -1645,7 +1465,7 @@
             <a:spLocks noGrp="1"/>
           </p:cNvSpPr>
           <p:nvPr>
-            <p:ph type="dt" idx="1"/>
+            <p:ph type="dt" idx="3"/>
           </p:nvPr>
         </p:nvSpPr>
         <p:spPr/>
@@ -1694,7 +1514,7 @@
         <p:spPr>
           <a:xfrm>
             <a:off x="1523880" y="1122480"/>
-            <a:ext cx="9143640" cy="11066760"/>
+            <a:ext cx="9143280" cy="11064960"/>
           </a:xfrm>
           <a:prstGeom prst="rect">
             <a:avLst/>
@@ -1725,7 +1545,7 @@
             <a:spLocks noGrp="1"/>
           </p:cNvSpPr>
           <p:nvPr>
-            <p:ph type="ftr" idx="2"/>
+            <p:ph type="ftr" idx="1"/>
           </p:nvPr>
         </p:nvSpPr>
         <p:spPr/>
@@ -1745,14 +1565,14 @@
             <a:spLocks noGrp="1"/>
           </p:cNvSpPr>
           <p:nvPr>
-            <p:ph type="sldNum" idx="3"/>
+            <p:ph type="sldNum" idx="2"/>
           </p:nvPr>
         </p:nvSpPr>
         <p:spPr/>
         <p:txBody>
           <a:bodyPr/>
           <a:p>
-            <a:fld id="{ED907A6C-6367-41F8-8703-972EE10D1242}" type="slidenum">
+            <a:fld id="{D84FB69E-360B-4DF1-B6D0-4E478AACBED6}" type="slidenum">
               <a:t>&lt;#&gt;</a:t>
             </a:fld>
           </a:p>
@@ -1765,7 +1585,7 @@
             <a:spLocks noGrp="1"/>
           </p:cNvSpPr>
           <p:nvPr>
-            <p:ph type="dt" idx="1"/>
+            <p:ph type="dt" idx="3"/>
           </p:nvPr>
         </p:nvSpPr>
         <p:spPr/>
@@ -1814,7 +1634,7 @@
         <p:spPr>
           <a:xfrm>
             <a:off x="1523880" y="1122480"/>
-            <a:ext cx="9143640" cy="2387160"/>
+            <a:ext cx="9143280" cy="2386800"/>
           </a:xfrm>
           <a:prstGeom prst="rect">
             <a:avLst/>
@@ -1829,11 +1649,11 @@
             <a:noAutofit/>
           </a:bodyPr>
           <a:p>
-            <a:endParaRPr b="0" lang="en-US" sz="1800" spc="-1" strike="noStrike">
-              <a:solidFill>
-                <a:srgbClr val="000000"/>
-              </a:solidFill>
-              <a:latin typeface="맑은 고딕"/>
+            <a:pPr algn="ctr">
+              <a:buNone/>
+            </a:pPr>
+            <a:endParaRPr b="0" lang="en-US" sz="4400" spc="-1" strike="noStrike">
+              <a:latin typeface="Arial"/>
             </a:endParaRPr>
           </a:p>
         </p:txBody>
@@ -1866,20 +1686,8 @@
             <a:normAutofit/>
           </a:bodyPr>
           <a:p>
-            <a:pPr>
-              <a:lnSpc>
-                <a:spcPct val="90000"/>
-              </a:lnSpc>
-              <a:spcBef>
-                <a:spcPts val="1417"/>
-              </a:spcBef>
-              <a:buNone/>
-            </a:pPr>
-            <a:endParaRPr b="0" lang="en-US" sz="2800" spc="-1" strike="noStrike">
-              <a:solidFill>
-                <a:srgbClr val="000000"/>
-              </a:solidFill>
-              <a:latin typeface="맑은 고딕"/>
+            <a:endParaRPr b="0" lang="en-US" sz="3200" spc="-1" strike="noStrike">
+              <a:latin typeface="Arial"/>
             </a:endParaRPr>
           </a:p>
         </p:txBody>
@@ -1912,20 +1720,8 @@
             <a:normAutofit/>
           </a:bodyPr>
           <a:p>
-            <a:pPr>
-              <a:lnSpc>
-                <a:spcPct val="90000"/>
-              </a:lnSpc>
-              <a:spcBef>
-                <a:spcPts val="1417"/>
-              </a:spcBef>
-              <a:buNone/>
-            </a:pPr>
-            <a:endParaRPr b="0" lang="en-US" sz="2800" spc="-1" strike="noStrike">
-              <a:solidFill>
-                <a:srgbClr val="000000"/>
-              </a:solidFill>
-              <a:latin typeface="맑은 고딕"/>
+            <a:endParaRPr b="0" lang="en-US" sz="3200" spc="-1" strike="noStrike">
+              <a:latin typeface="Arial"/>
             </a:endParaRPr>
           </a:p>
         </p:txBody>
@@ -1958,20 +1754,8 @@
             <a:normAutofit/>
           </a:bodyPr>
           <a:p>
-            <a:pPr>
-              <a:lnSpc>
-                <a:spcPct val="90000"/>
-              </a:lnSpc>
-              <a:spcBef>
-                <a:spcPts val="1417"/>
-              </a:spcBef>
-              <a:buNone/>
-            </a:pPr>
-            <a:endParaRPr b="0" lang="en-US" sz="2800" spc="-1" strike="noStrike">
-              <a:solidFill>
-                <a:srgbClr val="000000"/>
-              </a:solidFill>
-              <a:latin typeface="맑은 고딕"/>
+            <a:endParaRPr b="0" lang="en-US" sz="3200" spc="-1" strike="noStrike">
+              <a:latin typeface="Arial"/>
             </a:endParaRPr>
           </a:p>
         </p:txBody>
@@ -1983,7 +1767,7 @@
             <a:spLocks noGrp="1"/>
           </p:cNvSpPr>
           <p:nvPr>
-            <p:ph type="ftr" idx="2"/>
+            <p:ph type="ftr" idx="1"/>
           </p:nvPr>
         </p:nvSpPr>
         <p:spPr/>
@@ -2003,14 +1787,14 @@
             <a:spLocks noGrp="1"/>
           </p:cNvSpPr>
           <p:nvPr>
-            <p:ph type="sldNum" idx="3"/>
+            <p:ph type="sldNum" idx="2"/>
           </p:nvPr>
         </p:nvSpPr>
         <p:spPr/>
         <p:txBody>
           <a:bodyPr/>
           <a:p>
-            <a:fld id="{2086F05F-AF13-493D-98DA-4532AD950B9F}" type="slidenum">
+            <a:fld id="{530DAE5E-16BA-43A2-B3F7-08CFD434449D}" type="slidenum">
               <a:t>&lt;#&gt;</a:t>
             </a:fld>
           </a:p>
@@ -2023,7 +1807,7 @@
             <a:spLocks noGrp="1"/>
           </p:cNvSpPr>
           <p:nvPr>
-            <p:ph type="dt" idx="1"/>
+            <p:ph type="dt" idx="3"/>
           </p:nvPr>
         </p:nvSpPr>
         <p:spPr/>
@@ -2072,7 +1856,7 @@
         <p:spPr>
           <a:xfrm>
             <a:off x="1523880" y="1122480"/>
-            <a:ext cx="9143640" cy="2387160"/>
+            <a:ext cx="9143280" cy="2386800"/>
           </a:xfrm>
           <a:prstGeom prst="rect">
             <a:avLst/>
@@ -2087,11 +1871,11 @@
             <a:noAutofit/>
           </a:bodyPr>
           <a:p>
-            <a:endParaRPr b="0" lang="en-US" sz="1800" spc="-1" strike="noStrike">
-              <a:solidFill>
-                <a:srgbClr val="000000"/>
-              </a:solidFill>
-              <a:latin typeface="맑은 고딕"/>
+            <a:pPr algn="ctr">
+              <a:buNone/>
+            </a:pPr>
+            <a:endParaRPr b="0" lang="en-US" sz="4400" spc="-1" strike="noStrike">
+              <a:latin typeface="Arial"/>
             </a:endParaRPr>
           </a:p>
         </p:txBody>
@@ -2124,20 +1908,8 @@
             <a:normAutofit/>
           </a:bodyPr>
           <a:p>
-            <a:pPr>
-              <a:lnSpc>
-                <a:spcPct val="90000"/>
-              </a:lnSpc>
-              <a:spcBef>
-                <a:spcPts val="1417"/>
-              </a:spcBef>
-              <a:buNone/>
-            </a:pPr>
-            <a:endParaRPr b="0" lang="en-US" sz="2800" spc="-1" strike="noStrike">
-              <a:solidFill>
-                <a:srgbClr val="000000"/>
-              </a:solidFill>
-              <a:latin typeface="맑은 고딕"/>
+            <a:endParaRPr b="0" lang="en-US" sz="3200" spc="-1" strike="noStrike">
+              <a:latin typeface="Arial"/>
             </a:endParaRPr>
           </a:p>
         </p:txBody>
@@ -2170,20 +1942,8 @@
             <a:normAutofit/>
           </a:bodyPr>
           <a:p>
-            <a:pPr>
-              <a:lnSpc>
-                <a:spcPct val="90000"/>
-              </a:lnSpc>
-              <a:spcBef>
-                <a:spcPts val="1417"/>
-              </a:spcBef>
-              <a:buNone/>
-            </a:pPr>
-            <a:endParaRPr b="0" lang="en-US" sz="2800" spc="-1" strike="noStrike">
-              <a:solidFill>
-                <a:srgbClr val="000000"/>
-              </a:solidFill>
-              <a:latin typeface="맑은 고딕"/>
+            <a:endParaRPr b="0" lang="en-US" sz="3200" spc="-1" strike="noStrike">
+              <a:latin typeface="Arial"/>
             </a:endParaRPr>
           </a:p>
         </p:txBody>
@@ -2216,20 +1976,8 @@
             <a:normAutofit/>
           </a:bodyPr>
           <a:p>
-            <a:pPr>
-              <a:lnSpc>
-                <a:spcPct val="90000"/>
-              </a:lnSpc>
-              <a:spcBef>
-                <a:spcPts val="1417"/>
-              </a:spcBef>
-              <a:buNone/>
-            </a:pPr>
-            <a:endParaRPr b="0" lang="en-US" sz="2800" spc="-1" strike="noStrike">
-              <a:solidFill>
-                <a:srgbClr val="000000"/>
-              </a:solidFill>
-              <a:latin typeface="맑은 고딕"/>
+            <a:endParaRPr b="0" lang="en-US" sz="3200" spc="-1" strike="noStrike">
+              <a:latin typeface="Arial"/>
             </a:endParaRPr>
           </a:p>
         </p:txBody>
@@ -2241,7 +1989,7 @@
             <a:spLocks noGrp="1"/>
           </p:cNvSpPr>
           <p:nvPr>
-            <p:ph type="ftr" idx="2"/>
+            <p:ph type="ftr" idx="1"/>
           </p:nvPr>
         </p:nvSpPr>
         <p:spPr/>
@@ -2261,14 +2009,14 @@
             <a:spLocks noGrp="1"/>
           </p:cNvSpPr>
           <p:nvPr>
-            <p:ph type="sldNum" idx="3"/>
+            <p:ph type="sldNum" idx="2"/>
           </p:nvPr>
         </p:nvSpPr>
         <p:spPr/>
         <p:txBody>
           <a:bodyPr/>
           <a:p>
-            <a:fld id="{A6C06C59-02F0-4292-8558-32CC869F57A9}" type="slidenum">
+            <a:fld id="{E3317DC2-A99B-45A4-8759-651462E390AD}" type="slidenum">
               <a:t>&lt;#&gt;</a:t>
             </a:fld>
           </a:p>
@@ -2281,7 +2029,7 @@
             <a:spLocks noGrp="1"/>
           </p:cNvSpPr>
           <p:nvPr>
-            <p:ph type="dt" idx="1"/>
+            <p:ph type="dt" idx="3"/>
           </p:nvPr>
         </p:nvSpPr>
         <p:spPr/>
@@ -2330,7 +2078,7 @@
         <p:spPr>
           <a:xfrm>
             <a:off x="1523880" y="1122480"/>
-            <a:ext cx="9143640" cy="2387160"/>
+            <a:ext cx="9143280" cy="2386800"/>
           </a:xfrm>
           <a:prstGeom prst="rect">
             <a:avLst/>
@@ -2345,11 +2093,11 @@
             <a:noAutofit/>
           </a:bodyPr>
           <a:p>
-            <a:endParaRPr b="0" lang="en-US" sz="1800" spc="-1" strike="noStrike">
-              <a:solidFill>
-                <a:srgbClr val="000000"/>
-              </a:solidFill>
-              <a:latin typeface="맑은 고딕"/>
+            <a:pPr algn="ctr">
+              <a:buNone/>
+            </a:pPr>
+            <a:endParaRPr b="0" lang="en-US" sz="4400" spc="-1" strike="noStrike">
+              <a:latin typeface="Arial"/>
             </a:endParaRPr>
           </a:p>
         </p:txBody>
@@ -2382,20 +2130,8 @@
             <a:normAutofit/>
           </a:bodyPr>
           <a:p>
-            <a:pPr>
-              <a:lnSpc>
-                <a:spcPct val="90000"/>
-              </a:lnSpc>
-              <a:spcBef>
-                <a:spcPts val="1417"/>
-              </a:spcBef>
-              <a:buNone/>
-            </a:pPr>
-            <a:endParaRPr b="0" lang="en-US" sz="2800" spc="-1" strike="noStrike">
-              <a:solidFill>
-                <a:srgbClr val="000000"/>
-              </a:solidFill>
-              <a:latin typeface="맑은 고딕"/>
+            <a:endParaRPr b="0" lang="en-US" sz="3200" spc="-1" strike="noStrike">
+              <a:latin typeface="Arial"/>
             </a:endParaRPr>
           </a:p>
         </p:txBody>
@@ -2428,20 +2164,8 @@
             <a:normAutofit/>
           </a:bodyPr>
           <a:p>
-            <a:pPr>
-              <a:lnSpc>
-                <a:spcPct val="90000"/>
-              </a:lnSpc>
-              <a:spcBef>
-                <a:spcPts val="1417"/>
-              </a:spcBef>
-              <a:buNone/>
-            </a:pPr>
-            <a:endParaRPr b="0" lang="en-US" sz="2800" spc="-1" strike="noStrike">
-              <a:solidFill>
-                <a:srgbClr val="000000"/>
-              </a:solidFill>
-              <a:latin typeface="맑은 고딕"/>
+            <a:endParaRPr b="0" lang="en-US" sz="3200" spc="-1" strike="noStrike">
+              <a:latin typeface="Arial"/>
             </a:endParaRPr>
           </a:p>
         </p:txBody>
@@ -2474,20 +2198,8 @@
             <a:normAutofit/>
           </a:bodyPr>
           <a:p>
-            <a:pPr>
-              <a:lnSpc>
-                <a:spcPct val="90000"/>
-              </a:lnSpc>
-              <a:spcBef>
-                <a:spcPts val="1417"/>
-              </a:spcBef>
-              <a:buNone/>
-            </a:pPr>
-            <a:endParaRPr b="0" lang="en-US" sz="2800" spc="-1" strike="noStrike">
-              <a:solidFill>
-                <a:srgbClr val="000000"/>
-              </a:solidFill>
-              <a:latin typeface="맑은 고딕"/>
+            <a:endParaRPr b="0" lang="en-US" sz="3200" spc="-1" strike="noStrike">
+              <a:latin typeface="Arial"/>
             </a:endParaRPr>
           </a:p>
         </p:txBody>
@@ -2499,7 +2211,7 @@
             <a:spLocks noGrp="1"/>
           </p:cNvSpPr>
           <p:nvPr>
-            <p:ph type="ftr" idx="2"/>
+            <p:ph type="ftr" idx="1"/>
           </p:nvPr>
         </p:nvSpPr>
         <p:spPr/>
@@ -2519,14 +2231,14 @@
             <a:spLocks noGrp="1"/>
           </p:cNvSpPr>
           <p:nvPr>
-            <p:ph type="sldNum" idx="3"/>
+            <p:ph type="sldNum" idx="2"/>
           </p:nvPr>
         </p:nvSpPr>
         <p:spPr/>
         <p:txBody>
           <a:bodyPr/>
           <a:p>
-            <a:fld id="{DFA5527B-FB73-4926-B1FD-F4EEA779D41A}" type="slidenum">
+            <a:fld id="{21F50249-06C2-4AEF-A785-4FA4B3F7D997}" type="slidenum">
               <a:t>&lt;#&gt;</a:t>
             </a:fld>
           </a:p>
@@ -2539,7 +2251,7 @@
             <a:spLocks noGrp="1"/>
           </p:cNvSpPr>
           <p:nvPr>
-            <p:ph type="dt" idx="1"/>
+            <p:ph type="dt" idx="3"/>
           </p:nvPr>
         </p:nvSpPr>
         <p:spPr/>
@@ -2595,7 +2307,7 @@
         <p:spPr>
           <a:xfrm>
             <a:off x="1523880" y="1122480"/>
-            <a:ext cx="9143640" cy="2387160"/>
+            <a:ext cx="9143280" cy="2386800"/>
           </a:xfrm>
           <a:prstGeom prst="rect">
             <a:avLst/>
@@ -2606,138 +2318,48 @@
           </a:ln>
         </p:spPr>
         <p:txBody>
-          <a:bodyPr anchor="b">
+          <a:bodyPr lIns="0" rIns="0" tIns="0" bIns="0" anchor="ctr">
             <a:noAutofit/>
           </a:bodyPr>
           <a:p>
-            <a:pPr algn="ctr">
-              <a:lnSpc>
-                <a:spcPct val="90000"/>
-              </a:lnSpc>
-              <a:buNone/>
-            </a:pPr>
-            <a:r>
-              <a:rPr b="0" lang="ko-KR" sz="6000" spc="-1" strike="noStrike">
-                <a:solidFill>
-                  <a:srgbClr val="000000"/>
-                </a:solidFill>
-                <a:latin typeface="맑은 고딕"/>
+            <a:r>
+              <a:rPr b="0" lang="en-US" sz="1800" spc="-1" strike="noStrike">
+                <a:latin typeface="Arial"/>
               </a:rPr>
-              <a:t>마</a:t>
-            </a:r>
-            <a:r>
-              <a:rPr b="0" lang="ko-KR" sz="6000" spc="-1" strike="noStrike">
-                <a:solidFill>
-                  <a:srgbClr val="000000"/>
-                </a:solidFill>
-                <a:latin typeface="맑은 고딕"/>
+              <a:t>Click </a:t>
+            </a:r>
+            <a:r>
+              <a:rPr b="0" lang="en-US" sz="1800" spc="-1" strike="noStrike">
+                <a:latin typeface="Arial"/>
               </a:rPr>
-              <a:t>스</a:t>
-            </a:r>
-            <a:r>
-              <a:rPr b="0" lang="ko-KR" sz="6000" spc="-1" strike="noStrike">
-                <a:solidFill>
-                  <a:srgbClr val="000000"/>
-                </a:solidFill>
-                <a:latin typeface="맑은 고딕"/>
+              <a:t>to edit </a:t>
+            </a:r>
+            <a:r>
+              <a:rPr b="0" lang="en-US" sz="1800" spc="-1" strike="noStrike">
+                <a:latin typeface="Arial"/>
               </a:rPr>
-              <a:t>터</a:t>
-            </a:r>
-            <a:r>
-              <a:rPr b="0" lang="en-US" sz="6000" spc="-1" strike="noStrike">
-                <a:solidFill>
-                  <a:srgbClr val="000000"/>
-                </a:solidFill>
-                <a:latin typeface="맑은 고딕"/>
+              <a:t>the </a:t>
+            </a:r>
+            <a:r>
+              <a:rPr b="0" lang="en-US" sz="1800" spc="-1" strike="noStrike">
+                <a:latin typeface="Arial"/>
               </a:rPr>
-              <a:t> </a:t>
-            </a:r>
-            <a:r>
-              <a:rPr b="0" lang="ko-KR" sz="6000" spc="-1" strike="noStrike">
-                <a:solidFill>
-                  <a:srgbClr val="000000"/>
-                </a:solidFill>
-                <a:latin typeface="맑은 고딕"/>
+              <a:t>title </a:t>
+            </a:r>
+            <a:r>
+              <a:rPr b="0" lang="en-US" sz="1800" spc="-1" strike="noStrike">
+                <a:latin typeface="Arial"/>
               </a:rPr>
-              <a:t>제</a:t>
-            </a:r>
-            <a:r>
-              <a:rPr b="0" lang="ko-KR" sz="6000" spc="-1" strike="noStrike">
-                <a:solidFill>
-                  <a:srgbClr val="000000"/>
-                </a:solidFill>
-                <a:latin typeface="맑은 고딕"/>
+              <a:t>text </a:t>
+            </a:r>
+            <a:r>
+              <a:rPr b="0" lang="en-US" sz="1800" spc="-1" strike="noStrike">
+                <a:latin typeface="Arial"/>
               </a:rPr>
-              <a:t>목</a:t>
-            </a:r>
-            <a:r>
-              <a:rPr b="0" lang="en-US" sz="6000" spc="-1" strike="noStrike">
-                <a:solidFill>
-                  <a:srgbClr val="000000"/>
-                </a:solidFill>
-                <a:latin typeface="맑은 고딕"/>
-              </a:rPr>
-              <a:t> </a:t>
-            </a:r>
-            <a:r>
-              <a:rPr b="0" lang="ko-KR" sz="6000" spc="-1" strike="noStrike">
-                <a:solidFill>
-                  <a:srgbClr val="000000"/>
-                </a:solidFill>
-                <a:latin typeface="맑은 고딕"/>
-              </a:rPr>
-              <a:t>스</a:t>
-            </a:r>
-            <a:r>
-              <a:rPr b="0" lang="ko-KR" sz="6000" spc="-1" strike="noStrike">
-                <a:solidFill>
-                  <a:srgbClr val="000000"/>
-                </a:solidFill>
-                <a:latin typeface="맑은 고딕"/>
-              </a:rPr>
-              <a:t>타</a:t>
-            </a:r>
-            <a:r>
-              <a:rPr b="0" lang="ko-KR" sz="6000" spc="-1" strike="noStrike">
-                <a:solidFill>
-                  <a:srgbClr val="000000"/>
-                </a:solidFill>
-                <a:latin typeface="맑은 고딕"/>
-              </a:rPr>
-              <a:t>일</a:t>
-            </a:r>
-            <a:r>
-              <a:rPr b="0" lang="en-US" sz="6000" spc="-1" strike="noStrike">
-                <a:solidFill>
-                  <a:srgbClr val="000000"/>
-                </a:solidFill>
-                <a:latin typeface="맑은 고딕"/>
-              </a:rPr>
-              <a:t> </a:t>
-            </a:r>
-            <a:r>
-              <a:rPr b="0" lang="ko-KR" sz="6000" spc="-1" strike="noStrike">
-                <a:solidFill>
-                  <a:srgbClr val="000000"/>
-                </a:solidFill>
-                <a:latin typeface="맑은 고딕"/>
-              </a:rPr>
-              <a:t>편</a:t>
-            </a:r>
-            <a:r>
-              <a:rPr b="0" lang="ko-KR" sz="6000" spc="-1" strike="noStrike">
-                <a:solidFill>
-                  <a:srgbClr val="000000"/>
-                </a:solidFill>
-                <a:latin typeface="맑은 고딕"/>
-              </a:rPr>
-              <a:t>집</a:t>
-            </a:r>
-            <a:endParaRPr b="0" lang="en-US" sz="6000" spc="-1" strike="noStrike">
-              <a:solidFill>
-                <a:srgbClr val="000000"/>
-              </a:solidFill>
-              <a:latin typeface="맑은 고딕"/>
+              <a:t>format</a:t>
+            </a:r>
+            <a:endParaRPr b="0" lang="en-US" sz="1800" spc="-1" strike="noStrike">
+              <a:latin typeface="Arial"/>
             </a:endParaRPr>
           </a:p>
         </p:txBody>
@@ -2749,13 +2371,13 @@
             <a:spLocks noGrp="1"/>
           </p:cNvSpPr>
           <p:nvPr>
-            <p:ph type="dt" idx="1"/>
+            <p:ph type="ftr" idx="1"/>
           </p:nvPr>
         </p:nvSpPr>
         <p:spPr>
           <a:xfrm>
-            <a:off x="838080" y="6356520"/>
-            <a:ext cx="2742840" cy="364680"/>
+            <a:off x="4038480" y="6356520"/>
+            <a:ext cx="4114080" cy="364320"/>
           </a:xfrm>
           <a:prstGeom prst="rect">
             <a:avLst/>
@@ -2766,40 +2388,34 @@
           </a:ln>
         </p:spPr>
         <p:txBody>
-          <a:bodyPr anchor="ctr">
+          <a:bodyPr lIns="90000" rIns="90000" tIns="45000" bIns="45000" anchor="ctr">
             <a:noAutofit/>
           </a:bodyPr>
           <a:lstStyle>
-            <a:lvl1pPr>
+            <a:lvl1pPr algn="ctr">
               <a:lnSpc>
                 <a:spcPct val="100000"/>
               </a:lnSpc>
               <a:buNone/>
-              <a:defRPr b="0" lang="en-US" sz="1200" spc="-1" strike="noStrike">
-                <a:solidFill>
-                  <a:srgbClr val="8b8b8b"/>
-                </a:solidFill>
-                <a:latin typeface="맑은 고딕"/>
+              <a:defRPr b="0" lang="en-US" sz="1400" spc="-1" strike="noStrike">
+                <a:latin typeface="Times New Roman"/>
               </a:defRPr>
             </a:lvl1pPr>
           </a:lstStyle>
           <a:p>
-            <a:pPr>
+            <a:pPr algn="ctr">
               <a:lnSpc>
                 <a:spcPct val="100000"/>
               </a:lnSpc>
               <a:buNone/>
             </a:pPr>
             <a:r>
-              <a:rPr b="0" lang="en-US" sz="1200" spc="-1" strike="noStrike">
-                <a:solidFill>
-                  <a:srgbClr val="8b8b8b"/>
-                </a:solidFill>
-                <a:latin typeface="맑은 고딕"/>
+              <a:rPr b="0" lang="en-US" sz="1400" spc="-1" strike="noStrike">
+                <a:latin typeface="Times New Roman"/>
               </a:rPr>
-              <a:t>&lt;date/time&gt;</a:t>
-            </a:r>
-            <a:endParaRPr b="0" lang="en-US" sz="1200" spc="-1" strike="noStrike">
+              <a:t>&lt;footer&gt;</a:t>
+            </a:r>
+            <a:endParaRPr b="0" lang="en-US" sz="1400" spc="-1" strike="noStrike">
               <a:latin typeface="Times New Roman"/>
             </a:endParaRPr>
           </a:p>
@@ -2812,13 +2428,13 @@
             <a:spLocks noGrp="1"/>
           </p:cNvSpPr>
           <p:nvPr>
-            <p:ph type="ftr" idx="2"/>
+            <p:ph type="sldNum" idx="2"/>
           </p:nvPr>
         </p:nvSpPr>
         <p:spPr>
           <a:xfrm>
-            <a:off x="4038480" y="6356520"/>
-            <a:ext cx="4114440" cy="364680"/>
+            <a:off x="8610480" y="6356520"/>
+            <a:ext cx="2742480" cy="364320"/>
           </a:xfrm>
           <a:prstGeom prst="rect">
             <a:avLst/>
@@ -2829,58 +2445,7 @@
           </a:ln>
         </p:spPr>
         <p:txBody>
-          <a:bodyPr anchor="ctr">
-            <a:noAutofit/>
-          </a:bodyPr>
-          <a:lstStyle>
-            <a:lvl1pPr algn="ctr">
-              <a:buNone/>
-              <a:defRPr b="0" lang="en-US" sz="1400" spc="-1" strike="noStrike">
-                <a:latin typeface="Times New Roman"/>
-              </a:defRPr>
-            </a:lvl1pPr>
-          </a:lstStyle>
-          <a:p>
-            <a:pPr algn="ctr">
-              <a:buNone/>
-            </a:pPr>
-            <a:r>
-              <a:rPr b="0" lang="en-US" sz="1400" spc="-1" strike="noStrike">
-                <a:latin typeface="Times New Roman"/>
-              </a:rPr>
-              <a:t>&lt;footer&gt;</a:t>
-            </a:r>
-            <a:endParaRPr b="0" lang="en-US" sz="1400" spc="-1" strike="noStrike">
-              <a:latin typeface="Times New Roman"/>
-            </a:endParaRPr>
-          </a:p>
-        </p:txBody>
-      </p:sp>
-      <p:sp>
-        <p:nvSpPr>
-          <p:cNvPr id="3" name="PlaceHolder 4"/>
-          <p:cNvSpPr>
-            <a:spLocks noGrp="1"/>
-          </p:cNvSpPr>
-          <p:nvPr>
-            <p:ph type="sldNum" idx="3"/>
-          </p:nvPr>
-        </p:nvSpPr>
-        <p:spPr>
-          <a:xfrm>
-            <a:off x="8610480" y="6356520"/>
-            <a:ext cx="2742840" cy="364680"/>
-          </a:xfrm>
-          <a:prstGeom prst="rect">
-            <a:avLst/>
-          </a:prstGeom>
-          <a:noFill/>
-          <a:ln w="0">
-            <a:noFill/>
-          </a:ln>
-        </p:spPr>
-        <p:txBody>
-          <a:bodyPr anchor="ctr">
+          <a:bodyPr lIns="90000" rIns="90000" tIns="45000" bIns="45000" anchor="ctr">
             <a:noAutofit/>
           </a:bodyPr>
           <a:lstStyle>
@@ -2904,7 +2469,7 @@
               </a:lnSpc>
               <a:buNone/>
             </a:pPr>
-            <a:fld id="{B3172895-1797-48BE-9E88-C44EDD03858B}" type="slidenum">
+            <a:fld id="{B0A4BDF4-15E0-4876-A905-D3B38A80E6FF}" type="slidenum">
               <a:rPr b="0" lang="en-US" sz="1200" spc="-1" strike="noStrike">
                 <a:solidFill>
                   <a:srgbClr val="8b8b8b"/>
@@ -2914,6 +2479,53 @@
               <a:t>&lt;number&gt;</a:t>
             </a:fld>
             <a:endParaRPr b="0" lang="en-US" sz="1200" spc="-1" strike="noStrike">
+              <a:latin typeface="Times New Roman"/>
+            </a:endParaRPr>
+          </a:p>
+        </p:txBody>
+      </p:sp>
+      <p:sp>
+        <p:nvSpPr>
+          <p:cNvPr id="3" name="PlaceHolder 4"/>
+          <p:cNvSpPr>
+            <a:spLocks noGrp="1"/>
+          </p:cNvSpPr>
+          <p:nvPr>
+            <p:ph type="dt" idx="3"/>
+          </p:nvPr>
+        </p:nvSpPr>
+        <p:spPr>
+          <a:xfrm>
+            <a:off x="838080" y="6356520"/>
+            <a:ext cx="2742480" cy="364320"/>
+          </a:xfrm>
+          <a:prstGeom prst="rect">
+            <a:avLst/>
+          </a:prstGeom>
+          <a:noFill/>
+          <a:ln w="0">
+            <a:noFill/>
+          </a:ln>
+        </p:spPr>
+        <p:txBody>
+          <a:bodyPr lIns="90000" rIns="90000" tIns="45000" bIns="45000" anchor="ctr">
+            <a:noAutofit/>
+          </a:bodyPr>
+          <a:lstStyle>
+            <a:lvl1pPr>
+              <a:defRPr b="0" lang="en-US" sz="1400" spc="-1" strike="noStrike">
+                <a:latin typeface="Times New Roman"/>
+              </a:defRPr>
+            </a:lvl1pPr>
+          </a:lstStyle>
+          <a:p>
+            <a:r>
+              <a:rPr b="0" lang="en-US" sz="1400" spc="-1" strike="noStrike">
+                <a:latin typeface="Times New Roman"/>
+              </a:rPr>
+              <a:t>&lt;date/time&gt;</a:t>
+            </a:r>
+            <a:endParaRPr b="0" lang="en-US" sz="1400" spc="-1" strike="noStrike">
               <a:latin typeface="Times New Roman"/>
             </a:endParaRPr>
           </a:p>
@@ -2948,9 +2560,6 @@
           </a:bodyPr>
           <a:p>
             <a:pPr marL="432000" indent="-324000">
-              <a:lnSpc>
-                <a:spcPct val="90000"/>
-              </a:lnSpc>
               <a:spcBef>
                 <a:spcPts val="1417"/>
               </a:spcBef>
@@ -2962,26 +2571,17 @@
               <a:buChar char=""/>
             </a:pPr>
             <a:r>
-              <a:rPr b="0" lang="en-US" sz="2800" spc="-1" strike="noStrike">
-                <a:solidFill>
-                  <a:srgbClr val="000000"/>
-                </a:solidFill>
-                <a:latin typeface="맑은 고딕"/>
+              <a:rPr b="0" lang="en-US" sz="3200" spc="-1" strike="noStrike">
+                <a:latin typeface="Arial"/>
               </a:rPr>
               <a:t>Click to edit the outline text format</a:t>
             </a:r>
-            <a:endParaRPr b="0" lang="en-US" sz="2800" spc="-1" strike="noStrike">
-              <a:solidFill>
-                <a:srgbClr val="000000"/>
-              </a:solidFill>
-              <a:latin typeface="맑은 고딕"/>
+            <a:endParaRPr b="0" lang="en-US" sz="3200" spc="-1" strike="noStrike">
+              <a:latin typeface="Arial"/>
             </a:endParaRPr>
           </a:p>
           <a:p>
             <a:pPr lvl="1" marL="864000" indent="-324000">
-              <a:lnSpc>
-                <a:spcPct val="90000"/>
-              </a:lnSpc>
               <a:spcBef>
                 <a:spcPts val="1134"/>
               </a:spcBef>
@@ -2993,26 +2593,17 @@
               <a:buChar char=""/>
             </a:pPr>
             <a:r>
-              <a:rPr b="0" lang="en-US" sz="2000" spc="-1" strike="noStrike">
-                <a:solidFill>
-                  <a:srgbClr val="000000"/>
-                </a:solidFill>
-                <a:latin typeface="맑은 고딕"/>
+              <a:rPr b="0" lang="en-US" sz="2800" spc="-1" strike="noStrike">
+                <a:latin typeface="Arial"/>
               </a:rPr>
               <a:t>Second Outline Level</a:t>
             </a:r>
-            <a:endParaRPr b="0" lang="en-US" sz="2000" spc="-1" strike="noStrike">
-              <a:solidFill>
-                <a:srgbClr val="000000"/>
-              </a:solidFill>
-              <a:latin typeface="맑은 고딕"/>
+            <a:endParaRPr b="0" lang="en-US" sz="2800" spc="-1" strike="noStrike">
+              <a:latin typeface="Arial"/>
             </a:endParaRPr>
           </a:p>
           <a:p>
             <a:pPr lvl="2" marL="1296000" indent="-288000">
-              <a:lnSpc>
-                <a:spcPct val="90000"/>
-              </a:lnSpc>
               <a:spcBef>
                 <a:spcPts val="850"/>
               </a:spcBef>
@@ -3024,26 +2615,17 @@
               <a:buChar char=""/>
             </a:pPr>
             <a:r>
-              <a:rPr b="0" lang="en-US" sz="1800" spc="-1" strike="noStrike">
-                <a:solidFill>
-                  <a:srgbClr val="000000"/>
-                </a:solidFill>
-                <a:latin typeface="맑은 고딕"/>
+              <a:rPr b="0" lang="en-US" sz="2400" spc="-1" strike="noStrike">
+                <a:latin typeface="Arial"/>
               </a:rPr>
               <a:t>Third Outline Level</a:t>
             </a:r>
-            <a:endParaRPr b="0" lang="en-US" sz="1800" spc="-1" strike="noStrike">
-              <a:solidFill>
-                <a:srgbClr val="000000"/>
-              </a:solidFill>
-              <a:latin typeface="맑은 고딕"/>
+            <a:endParaRPr b="0" lang="en-US" sz="2400" spc="-1" strike="noStrike">
+              <a:latin typeface="Arial"/>
             </a:endParaRPr>
           </a:p>
           <a:p>
             <a:pPr lvl="3" marL="1728000" indent="-216000">
-              <a:lnSpc>
-                <a:spcPct val="90000"/>
-              </a:lnSpc>
               <a:spcBef>
                 <a:spcPts val="567"/>
               </a:spcBef>
@@ -3055,26 +2637,17 @@
               <a:buChar char=""/>
             </a:pPr>
             <a:r>
-              <a:rPr b="0" lang="en-US" sz="1800" spc="-1" strike="noStrike">
-                <a:solidFill>
-                  <a:srgbClr val="000000"/>
-                </a:solidFill>
-                <a:latin typeface="맑은 고딕"/>
+              <a:rPr b="0" lang="en-US" sz="2000" spc="-1" strike="noStrike">
+                <a:latin typeface="Arial"/>
               </a:rPr>
               <a:t>Fourth Outline Level</a:t>
             </a:r>
-            <a:endParaRPr b="0" lang="en-US" sz="1800" spc="-1" strike="noStrike">
-              <a:solidFill>
-                <a:srgbClr val="000000"/>
-              </a:solidFill>
-              <a:latin typeface="맑은 고딕"/>
+            <a:endParaRPr b="0" lang="en-US" sz="2000" spc="-1" strike="noStrike">
+              <a:latin typeface="Arial"/>
             </a:endParaRPr>
           </a:p>
           <a:p>
             <a:pPr lvl="4" marL="2160000" indent="-216000">
-              <a:lnSpc>
-                <a:spcPct val="90000"/>
-              </a:lnSpc>
               <a:spcBef>
                 <a:spcPts val="283"/>
               </a:spcBef>
@@ -3087,25 +2660,16 @@
             </a:pPr>
             <a:r>
               <a:rPr b="0" lang="en-US" sz="2000" spc="-1" strike="noStrike">
-                <a:solidFill>
-                  <a:srgbClr val="000000"/>
-                </a:solidFill>
-                <a:latin typeface="맑은 고딕"/>
+                <a:latin typeface="Arial"/>
               </a:rPr>
               <a:t>Fifth Outline Level</a:t>
             </a:r>
             <a:endParaRPr b="0" lang="en-US" sz="2000" spc="-1" strike="noStrike">
-              <a:solidFill>
-                <a:srgbClr val="000000"/>
-              </a:solidFill>
-              <a:latin typeface="맑은 고딕"/>
+              <a:latin typeface="Arial"/>
             </a:endParaRPr>
           </a:p>
           <a:p>
             <a:pPr lvl="5" marL="2592000" indent="-216000">
-              <a:lnSpc>
-                <a:spcPct val="90000"/>
-              </a:lnSpc>
               <a:spcBef>
                 <a:spcPts val="283"/>
               </a:spcBef>
@@ -3118,25 +2682,16 @@
             </a:pPr>
             <a:r>
               <a:rPr b="0" lang="en-US" sz="2000" spc="-1" strike="noStrike">
-                <a:solidFill>
-                  <a:srgbClr val="000000"/>
-                </a:solidFill>
-                <a:latin typeface="맑은 고딕"/>
+                <a:latin typeface="Arial"/>
               </a:rPr>
               <a:t>Sixth Outline Level</a:t>
             </a:r>
             <a:endParaRPr b="0" lang="en-US" sz="2000" spc="-1" strike="noStrike">
-              <a:solidFill>
-                <a:srgbClr val="000000"/>
-              </a:solidFill>
-              <a:latin typeface="맑은 고딕"/>
+              <a:latin typeface="Arial"/>
             </a:endParaRPr>
           </a:p>
           <a:p>
             <a:pPr lvl="6" marL="3024000" indent="-216000">
-              <a:lnSpc>
-                <a:spcPct val="90000"/>
-              </a:lnSpc>
               <a:spcBef>
                 <a:spcPts val="283"/>
               </a:spcBef>
@@ -3149,18 +2704,12 @@
             </a:pPr>
             <a:r>
               <a:rPr b="0" lang="en-US" sz="2000" spc="-1" strike="noStrike">
-                <a:solidFill>
-                  <a:srgbClr val="000000"/>
-                </a:solidFill>
-                <a:latin typeface="맑은 고딕"/>
+                <a:latin typeface="Arial"/>
               </a:rPr>
               <a:t>Seventh Outline Level</a:t>
             </a:r>
             <a:endParaRPr b="0" lang="en-US" sz="2000" spc="-1" strike="noStrike">
-              <a:solidFill>
-                <a:srgbClr val="000000"/>
-              </a:solidFill>
-              <a:latin typeface="맑은 고딕"/>
+              <a:latin typeface="Arial"/>
             </a:endParaRPr>
           </a:p>
         </p:txBody>
@@ -3211,7 +2760,7 @@
         <p:spPr>
           <a:xfrm>
             <a:off x="1559880" y="1576080"/>
-            <a:ext cx="1513080" cy="1995120"/>
+            <a:ext cx="1512720" cy="1994760"/>
           </a:xfrm>
           <a:prstGeom prst="rect">
             <a:avLst/>
@@ -3256,6 +2805,7 @@
                   <a:srgbClr val="ffffff"/>
                 </a:solidFill>
                 <a:latin typeface="맑은 고딕"/>
+                <a:ea typeface="DejaVu Sans"/>
               </a:rPr>
               <a:t>부품</a:t>
             </a:r>
@@ -3276,6 +2826,7 @@
                   <a:srgbClr val="ffffff"/>
                 </a:solidFill>
                 <a:latin typeface="맑은 고딕"/>
+                <a:ea typeface="DejaVu Sans"/>
               </a:rPr>
               <a:t>적재함</a:t>
             </a:r>
@@ -3294,7 +2845,7 @@
         <p:spPr>
           <a:xfrm>
             <a:off x="3929760" y="2349000"/>
-            <a:ext cx="880200" cy="869040"/>
+            <a:ext cx="879840" cy="868680"/>
           </a:xfrm>
           <a:prstGeom prst="ellipse">
             <a:avLst/>
@@ -3339,6 +2890,7 @@
                   <a:srgbClr val="ffffff"/>
                 </a:solidFill>
                 <a:latin typeface="맑은 고딕"/>
+                <a:ea typeface="DejaVu Sans"/>
               </a:rPr>
               <a:t>로봇</a:t>
             </a:r>
@@ -3348,6 +2900,7 @@
                   <a:srgbClr val="ffffff"/>
                 </a:solidFill>
                 <a:latin typeface="맑은 고딕"/>
+                <a:ea typeface="DejaVu Sans"/>
               </a:rPr>
               <a:t>1</a:t>
             </a:r>
@@ -3366,7 +2919,7 @@
         <p:spPr>
           <a:xfrm>
             <a:off x="7403400" y="2349000"/>
-            <a:ext cx="880200" cy="869040"/>
+            <a:ext cx="879840" cy="868680"/>
           </a:xfrm>
           <a:prstGeom prst="ellipse">
             <a:avLst/>
@@ -3411,6 +2964,7 @@
                   <a:srgbClr val="ffffff"/>
                 </a:solidFill>
                 <a:latin typeface="맑은 고딕"/>
+                <a:ea typeface="DejaVu Sans"/>
               </a:rPr>
               <a:t>로봇</a:t>
             </a:r>
@@ -3420,6 +2974,7 @@
                   <a:srgbClr val="ffffff"/>
                 </a:solidFill>
                 <a:latin typeface="맑은 고딕"/>
+                <a:ea typeface="DejaVu Sans"/>
               </a:rPr>
               <a:t>2</a:t>
             </a:r>
@@ -3438,7 +2993,7 @@
         <p:spPr>
           <a:xfrm>
             <a:off x="3073320" y="3753720"/>
-            <a:ext cx="6044760" cy="1350000"/>
+            <a:ext cx="6044400" cy="1349640"/>
           </a:xfrm>
           <a:prstGeom prst="rect">
             <a:avLst/>
@@ -3476,7 +3031,7 @@
         <p:spPr>
           <a:xfrm>
             <a:off x="9118440" y="1576080"/>
-            <a:ext cx="1513080" cy="1995120"/>
+            <a:ext cx="1512720" cy="1994760"/>
           </a:xfrm>
           <a:prstGeom prst="rect">
             <a:avLst/>
@@ -3521,6 +3076,7 @@
                   <a:srgbClr val="ffffff"/>
                 </a:solidFill>
                 <a:latin typeface="맑은 고딕"/>
+                <a:ea typeface="DejaVu Sans"/>
               </a:rPr>
               <a:t>완성품</a:t>
             </a:r>
@@ -3541,6 +3097,7 @@
                   <a:srgbClr val="ffffff"/>
                 </a:solidFill>
                 <a:latin typeface="맑은 고딕"/>
+                <a:ea typeface="DejaVu Sans"/>
               </a:rPr>
               <a:t>적재함</a:t>
             </a:r>
@@ -3559,7 +3116,7 @@
         <p:spPr>
           <a:xfrm>
             <a:off x="5085360" y="3954600"/>
-            <a:ext cx="2043000" cy="947880"/>
+            <a:ext cx="2042640" cy="947520"/>
           </a:xfrm>
           <a:prstGeom prst="rect">
             <a:avLst/>
@@ -3604,6 +3161,7 @@
                   <a:srgbClr val="ffffff"/>
                 </a:solidFill>
                 <a:latin typeface="맑은 고딕"/>
+                <a:ea typeface="DejaVu Sans"/>
               </a:rPr>
               <a:t>작업자</a:t>
             </a:r>
@@ -3624,6 +3182,7 @@
                   <a:srgbClr val="ffffff"/>
                 </a:solidFill>
                 <a:latin typeface="맑은 고딕"/>
+                <a:ea typeface="DejaVu Sans"/>
               </a:rPr>
               <a:t>작업 공간</a:t>
             </a:r>
@@ -3642,7 +3201,7 @@
         <p:spPr>
           <a:xfrm>
             <a:off x="7376760" y="3954600"/>
-            <a:ext cx="1501200" cy="947880"/>
+            <a:ext cx="1500840" cy="947520"/>
           </a:xfrm>
           <a:prstGeom prst="rect">
             <a:avLst/>
@@ -3687,6 +3246,7 @@
                   <a:srgbClr val="ffffff"/>
                 </a:solidFill>
                 <a:latin typeface="맑은 고딕"/>
+                <a:ea typeface="DejaVu Sans"/>
               </a:rPr>
               <a:t>검수 공간</a:t>
             </a:r>
@@ -3705,7 +3265,7 @@
         <p:spPr>
           <a:xfrm>
             <a:off x="3335400" y="3954600"/>
-            <a:ext cx="1501200" cy="947880"/>
+            <a:ext cx="1500840" cy="947520"/>
           </a:xfrm>
           <a:prstGeom prst="rect">
             <a:avLst/>
@@ -3750,6 +3310,7 @@
                   <a:srgbClr val="ffffff"/>
                 </a:solidFill>
                 <a:latin typeface="맑은 고딕"/>
+                <a:ea typeface="DejaVu Sans"/>
               </a:rPr>
               <a:t>부품 대기 공간</a:t>
             </a:r>
@@ -3768,7 +3329,7 @@
         <p:spPr>
           <a:xfrm>
             <a:off x="5666760" y="1576080"/>
-            <a:ext cx="880200" cy="1995120"/>
+            <a:ext cx="879840" cy="1994760"/>
           </a:xfrm>
           <a:prstGeom prst="rect">
             <a:avLst/>
@@ -3813,6 +3374,7 @@
                   <a:srgbClr val="ffffff"/>
                 </a:solidFill>
                 <a:latin typeface="맑은 고딕"/>
+                <a:ea typeface="DejaVu Sans"/>
               </a:rPr>
               <a:t>불량품</a:t>
             </a:r>
@@ -3833,6 +3395,7 @@
                   <a:srgbClr val="ffffff"/>
                 </a:solidFill>
                 <a:latin typeface="맑은 고딕"/>
+                <a:ea typeface="DejaVu Sans"/>
               </a:rPr>
               <a:t>적재함</a:t>
             </a:r>
@@ -3851,7 +3414,7 @@
         <p:spPr>
           <a:xfrm>
             <a:off x="5759640" y="5285880"/>
-            <a:ext cx="671760" cy="608760"/>
+            <a:ext cx="671400" cy="608400"/>
           </a:xfrm>
           <a:prstGeom prst="ellipse">
             <a:avLst/>
@@ -3896,6 +3459,7 @@
                   <a:srgbClr val="ffffff"/>
                 </a:solidFill>
                 <a:latin typeface="맑은 고딕"/>
+                <a:ea typeface="DejaVu Sans"/>
               </a:rPr>
               <a:t>작업자</a:t>
             </a:r>
@@ -3913,8 +3477,8 @@
         </p:nvSpPr>
         <p:spPr>
           <a:xfrm>
-            <a:off x="5371200" y="593640"/>
-            <a:ext cx="1448640" cy="363960"/>
+            <a:off x="5367240" y="593640"/>
+            <a:ext cx="1456200" cy="363960"/>
           </a:xfrm>
           <a:prstGeom prst="rect">
             <a:avLst/>
@@ -3947,6 +3511,7 @@
                   <a:srgbClr val="000000"/>
                 </a:solidFill>
                 <a:latin typeface="맑은 고딕"/>
+                <a:ea typeface="DejaVu Sans"/>
               </a:rPr>
               <a:t>&lt;</a:t>
             </a:r>
@@ -3956,6 +3521,7 @@
                   <a:srgbClr val="000000"/>
                 </a:solidFill>
                 <a:latin typeface="맑은 고딕"/>
+                <a:ea typeface="DejaVu Sans"/>
               </a:rPr>
               <a:t>작업 공간</a:t>
             </a:r>
@@ -3965,6 +3531,7 @@
                   <a:srgbClr val="000000"/>
                 </a:solidFill>
                 <a:latin typeface="맑은 고딕"/>
+                <a:ea typeface="DejaVu Sans"/>
               </a:rPr>
               <a:t>&gt;</a:t>
             </a:r>
@@ -4013,9 +3580,9 @@
         <p:grpSpPr>
           <a:xfrm>
             <a:off x="1676880" y="425160"/>
-            <a:ext cx="8838000" cy="6007320"/>
+            <a:ext cx="8837640" cy="6006960"/>
             <a:chOff x="1676880" y="425160"/>
-            <a:chExt cx="8838000" cy="6007320"/>
+            <a:chExt cx="8837640" cy="6006960"/>
           </a:xfrm>
         </p:grpSpPr>
         <p:sp>
@@ -4027,7 +3594,7 @@
           <p:spPr>
             <a:xfrm>
               <a:off x="4860000" y="1596600"/>
-              <a:ext cx="2471760" cy="3668400"/>
+              <a:ext cx="2471400" cy="3668040"/>
             </a:xfrm>
             <a:prstGeom prst="rect">
               <a:avLst/>
@@ -4065,7 +3632,7 @@
           <p:spPr>
             <a:xfrm>
               <a:off x="4978440" y="1693440"/>
-              <a:ext cx="2268720" cy="3454200"/>
+              <a:ext cx="2268360" cy="3453840"/>
             </a:xfrm>
             <a:prstGeom prst="rect">
               <a:avLst/>
@@ -4110,6 +3677,7 @@
                     <a:srgbClr val="ffffff"/>
                   </a:solidFill>
                   <a:latin typeface="맑은 고딕"/>
+                  <a:ea typeface="DejaVu Sans"/>
                 </a:rPr>
                 <a:t>물류 분류</a:t>
               </a:r>
@@ -4130,6 +3698,7 @@
                     <a:srgbClr val="ffffff"/>
                   </a:solidFill>
                   <a:latin typeface="맑은 고딕"/>
+                  <a:ea typeface="DejaVu Sans"/>
                 </a:rPr>
                 <a:t>작업대</a:t>
               </a:r>
@@ -4148,7 +3717,7 @@
           <p:spPr>
             <a:xfrm>
               <a:off x="3584880" y="2985120"/>
-              <a:ext cx="880200" cy="869040"/>
+              <a:ext cx="879840" cy="868680"/>
             </a:xfrm>
             <a:prstGeom prst="ellipse">
               <a:avLst/>
@@ -4193,6 +3762,7 @@
                     <a:srgbClr val="ffffff"/>
                   </a:solidFill>
                   <a:latin typeface="맑은 고딕"/>
+                  <a:ea typeface="DejaVu Sans"/>
                 </a:rPr>
                 <a:t>로봇</a:t>
               </a:r>
@@ -4202,6 +3772,7 @@
                     <a:srgbClr val="ffffff"/>
                   </a:solidFill>
                   <a:latin typeface="맑은 고딕"/>
+                  <a:ea typeface="DejaVu Sans"/>
                 </a:rPr>
                 <a:t>1</a:t>
               </a:r>
@@ -4220,7 +3791,7 @@
           <p:spPr>
             <a:xfrm>
               <a:off x="7726680" y="2985120"/>
-              <a:ext cx="880200" cy="869040"/>
+              <a:ext cx="879840" cy="868680"/>
             </a:xfrm>
             <a:prstGeom prst="ellipse">
               <a:avLst/>
@@ -4265,6 +3836,7 @@
                     <a:srgbClr val="ffffff"/>
                   </a:solidFill>
                   <a:latin typeface="맑은 고딕"/>
+                  <a:ea typeface="DejaVu Sans"/>
                 </a:rPr>
                 <a:t>로봇</a:t>
               </a:r>
@@ -4274,6 +3846,7 @@
                     <a:srgbClr val="ffffff"/>
                   </a:solidFill>
                   <a:latin typeface="맑은 고딕"/>
+                  <a:ea typeface="DejaVu Sans"/>
                 </a:rPr>
                 <a:t>2</a:t>
               </a:r>
@@ -4292,7 +3865,7 @@
           <p:spPr>
             <a:xfrm>
               <a:off x="1676880" y="1016640"/>
-              <a:ext cx="1513080" cy="1380960"/>
+              <a:ext cx="1512720" cy="1380600"/>
             </a:xfrm>
             <a:prstGeom prst="rect">
               <a:avLst/>
@@ -4337,6 +3910,7 @@
                     <a:srgbClr val="ffffff"/>
                   </a:solidFill>
                   <a:latin typeface="맑은 고딕"/>
+                  <a:ea typeface="DejaVu Sans"/>
                 </a:rPr>
                 <a:t>물류</a:t>
               </a:r>
@@ -4346,6 +3920,7 @@
                     <a:srgbClr val="ffffff"/>
                   </a:solidFill>
                   <a:latin typeface="맑은 고딕"/>
+                  <a:ea typeface="DejaVu Sans"/>
                 </a:rPr>
                 <a:t>A-Red</a:t>
               </a:r>
@@ -4366,6 +3941,7 @@
                     <a:srgbClr val="ffffff"/>
                   </a:solidFill>
                   <a:latin typeface="맑은 고딕"/>
+                  <a:ea typeface="DejaVu Sans"/>
                 </a:rPr>
                 <a:t>적재함</a:t>
               </a:r>
@@ -4384,7 +3960,7 @@
           <p:spPr>
             <a:xfrm>
               <a:off x="9001800" y="1016640"/>
-              <a:ext cx="1513080" cy="1380960"/>
+              <a:ext cx="1512720" cy="1380600"/>
             </a:xfrm>
             <a:prstGeom prst="rect">
               <a:avLst/>
@@ -4429,6 +4005,7 @@
                     <a:srgbClr val="ffffff"/>
                   </a:solidFill>
                   <a:latin typeface="맑은 고딕"/>
+                  <a:ea typeface="DejaVu Sans"/>
                 </a:rPr>
                 <a:t>물류</a:t>
               </a:r>
@@ -4438,6 +4015,7 @@
                     <a:srgbClr val="ffffff"/>
                   </a:solidFill>
                   <a:latin typeface="맑은 고딕"/>
+                  <a:ea typeface="DejaVu Sans"/>
                 </a:rPr>
                 <a:t>A-Green</a:t>
               </a:r>
@@ -4458,6 +4036,7 @@
                     <a:srgbClr val="ffffff"/>
                   </a:solidFill>
                   <a:latin typeface="맑은 고딕"/>
+                  <a:ea typeface="DejaVu Sans"/>
                 </a:rPr>
                 <a:t>적재함</a:t>
               </a:r>
@@ -4476,7 +4055,7 @@
           <p:spPr>
             <a:xfrm>
               <a:off x="1676880" y="2728800"/>
-              <a:ext cx="1513080" cy="1380960"/>
+              <a:ext cx="1512720" cy="1380600"/>
             </a:xfrm>
             <a:prstGeom prst="rect">
               <a:avLst/>
@@ -4521,6 +4100,7 @@
                     <a:srgbClr val="ffffff"/>
                   </a:solidFill>
                   <a:latin typeface="맑은 고딕"/>
+                  <a:ea typeface="DejaVu Sans"/>
                 </a:rPr>
                 <a:t>물류</a:t>
               </a:r>
@@ -4530,6 +4110,7 @@
                     <a:srgbClr val="ffffff"/>
                   </a:solidFill>
                   <a:latin typeface="맑은 고딕"/>
+                  <a:ea typeface="DejaVu Sans"/>
                 </a:rPr>
                 <a:t>B-Blue</a:t>
               </a:r>
@@ -4550,6 +4131,7 @@
                     <a:srgbClr val="ffffff"/>
                   </a:solidFill>
                   <a:latin typeface="맑은 고딕"/>
+                  <a:ea typeface="DejaVu Sans"/>
                 </a:rPr>
                 <a:t>적재함</a:t>
               </a:r>
@@ -4568,7 +4150,7 @@
           <p:spPr>
             <a:xfrm>
               <a:off x="9001800" y="2728800"/>
-              <a:ext cx="1513080" cy="1380960"/>
+              <a:ext cx="1512720" cy="1380600"/>
             </a:xfrm>
             <a:prstGeom prst="rect">
               <a:avLst/>
@@ -4613,6 +4195,7 @@
                     <a:srgbClr val="ffffff"/>
                   </a:solidFill>
                   <a:latin typeface="맑은 고딕"/>
+                  <a:ea typeface="DejaVu Sans"/>
                 </a:rPr>
                 <a:t>물류</a:t>
               </a:r>
@@ -4622,6 +4205,7 @@
                     <a:srgbClr val="ffffff"/>
                   </a:solidFill>
                   <a:latin typeface="맑은 고딕"/>
+                  <a:ea typeface="DejaVu Sans"/>
                 </a:rPr>
                 <a:t>B-Red</a:t>
               </a:r>
@@ -4642,6 +4226,7 @@
                     <a:srgbClr val="ffffff"/>
                   </a:solidFill>
                   <a:latin typeface="맑은 고딕"/>
+                  <a:ea typeface="DejaVu Sans"/>
                 </a:rPr>
                 <a:t>적재함</a:t>
               </a:r>
@@ -4660,7 +4245,7 @@
           <p:spPr>
             <a:xfrm>
               <a:off x="1676880" y="4441320"/>
-              <a:ext cx="1513080" cy="1380960"/>
+              <a:ext cx="1512720" cy="1380600"/>
             </a:xfrm>
             <a:prstGeom prst="rect">
               <a:avLst/>
@@ -4705,6 +4290,7 @@
                     <a:srgbClr val="ffffff"/>
                   </a:solidFill>
                   <a:latin typeface="맑은 고딕"/>
+                  <a:ea typeface="DejaVu Sans"/>
                 </a:rPr>
                 <a:t>물류</a:t>
               </a:r>
@@ -4714,6 +4300,7 @@
                     <a:srgbClr val="ffffff"/>
                   </a:solidFill>
                   <a:latin typeface="맑은 고딕"/>
+                  <a:ea typeface="DejaVu Sans"/>
                 </a:rPr>
                 <a:t>C-Green</a:t>
               </a:r>
@@ -4734,6 +4321,7 @@
                     <a:srgbClr val="ffffff"/>
                   </a:solidFill>
                   <a:latin typeface="맑은 고딕"/>
+                  <a:ea typeface="DejaVu Sans"/>
                 </a:rPr>
                 <a:t>적재함</a:t>
               </a:r>
@@ -4752,7 +4340,7 @@
           <p:spPr>
             <a:xfrm>
               <a:off x="9001800" y="4441320"/>
-              <a:ext cx="1513080" cy="1380960"/>
+              <a:ext cx="1512720" cy="1380600"/>
             </a:xfrm>
             <a:prstGeom prst="rect">
               <a:avLst/>
@@ -4797,6 +4385,7 @@
                     <a:srgbClr val="ffffff"/>
                   </a:solidFill>
                   <a:latin typeface="맑은 고딕"/>
+                  <a:ea typeface="DejaVu Sans"/>
                 </a:rPr>
                 <a:t>물류</a:t>
               </a:r>
@@ -4806,6 +4395,7 @@
                     <a:srgbClr val="ffffff"/>
                   </a:solidFill>
                   <a:latin typeface="맑은 고딕"/>
+                  <a:ea typeface="DejaVu Sans"/>
                 </a:rPr>
                 <a:t>C-Blue</a:t>
               </a:r>
@@ -4826,6 +4416,7 @@
                     <a:srgbClr val="ffffff"/>
                   </a:solidFill>
                   <a:latin typeface="맑은 고딕"/>
+                  <a:ea typeface="DejaVu Sans"/>
                 </a:rPr>
                 <a:t>적재함</a:t>
               </a:r>
@@ -4844,7 +4435,7 @@
           <p:spPr>
             <a:xfrm>
               <a:off x="5760000" y="5518080"/>
-              <a:ext cx="671760" cy="608760"/>
+              <a:ext cx="671400" cy="608400"/>
             </a:xfrm>
             <a:prstGeom prst="ellipse">
               <a:avLst/>
@@ -4889,6 +4480,7 @@
                     <a:srgbClr val="ffffff"/>
                   </a:solidFill>
                   <a:latin typeface="맑은 고딕"/>
+                  <a:ea typeface="DejaVu Sans"/>
                 </a:rPr>
                 <a:t>작업자</a:t>
               </a:r>
@@ -4907,7 +4499,7 @@
           <p:spPr>
             <a:xfrm>
               <a:off x="5760000" y="712080"/>
-              <a:ext cx="671760" cy="608760"/>
+              <a:ext cx="671400" cy="608400"/>
             </a:xfrm>
             <a:prstGeom prst="ellipse">
               <a:avLst/>
@@ -4952,6 +4544,7 @@
                     <a:srgbClr val="ffffff"/>
                   </a:solidFill>
                   <a:latin typeface="맑은 고딕"/>
+                  <a:ea typeface="DejaVu Sans"/>
                 </a:rPr>
                 <a:t>작업자</a:t>
               </a:r>
@@ -4970,7 +4563,7 @@
           <p:spPr>
             <a:xfrm>
               <a:off x="6036840" y="1370880"/>
-              <a:ext cx="118080" cy="176040"/>
+              <a:ext cx="117720" cy="175680"/>
             </a:xfrm>
             <a:prstGeom prst="downArrow">
               <a:avLst>
@@ -5010,8 +4603,8 @@
           </p:nvSpPr>
           <p:spPr>
             <a:xfrm rot="10800000">
-              <a:off x="6037200" y="5303880"/>
-              <a:ext cx="118080" cy="176040"/>
+              <a:off x="6037560" y="5304240"/>
+              <a:ext cx="117720" cy="175680"/>
             </a:xfrm>
             <a:prstGeom prst="downArrow">
               <a:avLst>
@@ -5052,7 +4645,7 @@
           <p:spPr>
             <a:xfrm>
               <a:off x="3995640" y="4432320"/>
-              <a:ext cx="864000" cy="828720"/>
+              <a:ext cx="863640" cy="828360"/>
             </a:xfrm>
             <a:prstGeom prst="rect">
               <a:avLst/>
@@ -5097,6 +4690,7 @@
                     <a:srgbClr val="ffffff"/>
                   </a:solidFill>
                   <a:latin typeface="맑은 고딕"/>
+                  <a:ea typeface="DejaVu Sans"/>
                 </a:rPr>
                 <a:t>분류</a:t>
               </a:r>
@@ -5117,6 +4711,7 @@
                     <a:srgbClr val="ffffff"/>
                   </a:solidFill>
                   <a:latin typeface="맑은 고딕"/>
+                  <a:ea typeface="DejaVu Sans"/>
                 </a:rPr>
                 <a:t>불가품</a:t>
               </a:r>
@@ -5135,7 +4730,7 @@
           <p:spPr>
             <a:xfrm>
               <a:off x="7332120" y="1596600"/>
-              <a:ext cx="864000" cy="828720"/>
+              <a:ext cx="863640" cy="828360"/>
             </a:xfrm>
             <a:prstGeom prst="rect">
               <a:avLst/>
@@ -5180,6 +4775,7 @@
                     <a:srgbClr val="ffffff"/>
                   </a:solidFill>
                   <a:latin typeface="맑은 고딕"/>
+                  <a:ea typeface="DejaVu Sans"/>
                 </a:rPr>
                 <a:t>분류</a:t>
               </a:r>
@@ -5200,6 +4796,7 @@
                     <a:srgbClr val="ffffff"/>
                   </a:solidFill>
                   <a:latin typeface="맑은 고딕"/>
+                  <a:ea typeface="DejaVu Sans"/>
                 </a:rPr>
                 <a:t>불가품</a:t>
               </a:r>
@@ -5218,7 +4815,7 @@
           <p:spPr>
             <a:xfrm>
               <a:off x="6036840" y="6212880"/>
-              <a:ext cx="118080" cy="176040"/>
+              <a:ext cx="117720" cy="175680"/>
             </a:xfrm>
             <a:prstGeom prst="downArrow">
               <a:avLst>
@@ -5258,8 +4855,8 @@
           </p:nvSpPr>
           <p:spPr>
             <a:xfrm rot="10800000">
-              <a:off x="6037200" y="488520"/>
-              <a:ext cx="118080" cy="176040"/>
+              <a:off x="6037560" y="488880"/>
+              <a:ext cx="117720" cy="175680"/>
             </a:xfrm>
             <a:prstGeom prst="downArrow">
               <a:avLst>
@@ -5300,7 +4897,7 @@
           <p:spPr>
             <a:xfrm>
               <a:off x="3995640" y="5261400"/>
-              <a:ext cx="864000" cy="1171080"/>
+              <a:ext cx="863640" cy="1170720"/>
             </a:xfrm>
             <a:prstGeom prst="rect">
               <a:avLst/>
@@ -5348,6 +4945,7 @@
                     <a:srgbClr val="ffffff"/>
                   </a:solidFill>
                   <a:latin typeface="맑은 고딕"/>
+                  <a:ea typeface="DejaVu Sans"/>
                 </a:rPr>
                 <a:t>컨베</a:t>
               </a:r>
@@ -5368,6 +4966,7 @@
                     <a:srgbClr val="ffffff"/>
                   </a:solidFill>
                   <a:latin typeface="맑은 고딕"/>
+                  <a:ea typeface="DejaVu Sans"/>
                 </a:rPr>
                 <a:t>이어</a:t>
               </a:r>
@@ -5388,6 +4987,7 @@
                     <a:srgbClr val="ffffff"/>
                   </a:solidFill>
                   <a:latin typeface="맑은 고딕"/>
+                  <a:ea typeface="DejaVu Sans"/>
                 </a:rPr>
                 <a:t>벨트</a:t>
               </a:r>
@@ -5417,7 +5017,7 @@
           <p:spPr>
             <a:xfrm>
               <a:off x="4368240" y="6124680"/>
-              <a:ext cx="118080" cy="176040"/>
+              <a:ext cx="117720" cy="175680"/>
             </a:xfrm>
             <a:prstGeom prst="downArrow">
               <a:avLst>
@@ -5458,7 +5058,7 @@
           <p:spPr>
             <a:xfrm>
               <a:off x="7332120" y="425160"/>
-              <a:ext cx="864000" cy="1171080"/>
+              <a:ext cx="863640" cy="1170720"/>
             </a:xfrm>
             <a:prstGeom prst="rect">
               <a:avLst/>
@@ -5517,6 +5117,7 @@
                     <a:srgbClr val="ffffff"/>
                   </a:solidFill>
                   <a:latin typeface="맑은 고딕"/>
+                  <a:ea typeface="DejaVu Sans"/>
                 </a:rPr>
                 <a:t>컨베</a:t>
               </a:r>
@@ -5537,6 +5138,7 @@
                     <a:srgbClr val="ffffff"/>
                   </a:solidFill>
                   <a:latin typeface="맑은 고딕"/>
+                  <a:ea typeface="DejaVu Sans"/>
                 </a:rPr>
                 <a:t>이어</a:t>
               </a:r>
@@ -5557,6 +5159,7 @@
                     <a:srgbClr val="ffffff"/>
                   </a:solidFill>
                   <a:latin typeface="맑은 고딕"/>
+                  <a:ea typeface="DejaVu Sans"/>
                 </a:rPr>
                 <a:t>벨트</a:t>
               </a:r>
@@ -5574,8 +5177,8 @@
           </p:nvSpPr>
           <p:spPr>
             <a:xfrm rot="10800000">
-              <a:off x="7688520" y="536040"/>
-              <a:ext cx="118080" cy="176040"/>
+              <a:off x="7688880" y="536400"/>
+              <a:ext cx="117720" cy="175680"/>
             </a:xfrm>
             <a:prstGeom prst="downArrow">
               <a:avLst>
@@ -5650,8 +5253,8 @@
         </p:blipFill>
         <p:spPr>
           <a:xfrm>
-            <a:off x="486000" y="1515240"/>
-            <a:ext cx="5457600" cy="3742200"/>
+            <a:off x="5715000" y="1600200"/>
+            <a:ext cx="6285240" cy="3429000"/>
           </a:xfrm>
           <a:prstGeom prst="rect">
             <a:avLst/>
@@ -5673,8 +5276,8 @@
         </p:blipFill>
         <p:spPr>
           <a:xfrm>
-            <a:off x="6172200" y="1665360"/>
-            <a:ext cx="5029200" cy="3363840"/>
+            <a:off x="374400" y="1479600"/>
+            <a:ext cx="5340600" cy="3657600"/>
           </a:xfrm>
           <a:prstGeom prst="rect">
             <a:avLst/>

</xml_diff>